<commit_message>
Actualiza presentacion y PDF con cambios finales
</commit_message>
<xml_diff>
--- a/Resultados_Challenge_ABInBev.pptx
+++ b/Resultados_Challenge_ABInBev.pptx
@@ -2154,10 +2154,7 @@
           <a:bodyPr/>
           <a:lstStyle/>
           <a:p>
-            <a:r>
-              <a:rPr lang="en-US" dirty="0"/>
-              <a:t>Encuadre: el modelo responde qué se asocia al volumen y con qué grado de evidencia. No es un modelo de pronóstico ni una herramienta de asignación automática de presupuesto.</a:t>
-            </a:r>
+            <a:endParaRPr lang="en-US" dirty="0"/>
           </a:p>
         </p:txBody>
       </p:sp>
@@ -2330,8 +2327,22 @@
           <a:p>
             <a:r>
               <a:rPr lang="en-US" dirty="0"/>
-              <a:t>Orden de las transformaciones: primero el adstock acumula la inversión con su memoria, después la saturación convierte esa presión acumulada en respuesta. Las curvas son ilustrativas y usan la misma forma funcional del modelo: A(t) = M(t) + θ·A(t−1) y S(A) = A^α / (A^α + γ^α). En ambas curvas de saturación, A = γ produce exactamente 50 % del efecto máximo. Los valores de cada canal están en la lámina siguiente.</a:t>
-            </a:r>
+              <a:t>Orden de las transformaciones: primero el adstock acumula la inversión con su memoria, después la saturación convierte esa presión acumulada en respuesta. Las curvas son ilustrativas y usan la misma forma funcional del modelo: A(t) = M(t) + θ·A(t−1) y S(A) = A^α / (A^α + γ^α). En ambas curvas de saturación, A = γ produce exactamente 50 % del efecto máximo. Los valores de cada canal están en la lámina </a:t>
+            </a:r>
+            <a:r>
+              <a:rPr lang="en-US" dirty="0" err="1"/>
+              <a:t>siguiente</a:t>
+            </a:r>
+            <a:r>
+              <a:rPr lang="en-US" dirty="0"/>
+              <a:t>.</a:t>
+            </a:r>
+          </a:p>
+          <a:p>
+            <a:endParaRPr lang="en-US" dirty="0"/>
+          </a:p>
+          <a:p>
+            <a:endParaRPr lang="en-US" dirty="0"/>
           </a:p>
         </p:txBody>
       </p:sp>
@@ -2417,8 +2428,19 @@
           <a:p>
             <a:r>
               <a:rPr lang="en-US" dirty="0"/>
-              <a:t>El criterio de 5% fijado ex ante es lo que impide elegir el modelo después de ver el resultado. Vale la pena señalarlo.</a:t>
-            </a:r>
+              <a:t>El criterio de 5% fijado ex ante es lo que impide elegir el modelo después de ver el resultado. Vale la pena </a:t>
+            </a:r>
+            <a:r>
+              <a:rPr lang="en-US" dirty="0" err="1"/>
+              <a:t>señalarlo</a:t>
+            </a:r>
+            <a:r>
+              <a:rPr lang="en-US" dirty="0"/>
+              <a:t>.</a:t>
+            </a:r>
+          </a:p>
+          <a:p>
+            <a:endParaRPr lang="en-US" dirty="0"/>
           </a:p>
         </p:txBody>
       </p:sp>
@@ -2504,8 +2526,3198 @@
           <a:p>
             <a:r>
               <a:rPr lang="en-US" dirty="0"/>
-              <a:t>Curvas construidas con los parámetros calibrados del notebook (θ, α y γ por canal) y la posición reciente A/γ que reporta la celda de saturación. Vida media del efecto: ln(0,5)/ln(θ), 0,6 semanas con θ = 0,3; 1 semana con θ = 0,5; 1,9 semanas con θ = 0,7. La posición en la curva describe la transformación, no el retorno: estar cerca del techo no obliga a recortar, pero sí indica que un peso adicional probablemente rinda poco. La decisión requiere además el coeficiente, su incertidumbre y el costo. Instagram y radio aparecen saturados, pero su coeficiente no es significativo.</a:t>
-            </a:r>
+              <a:t>Curvas construidas con los parámetros calibrados del notebook (θ, α y γ por canal) y la posición reciente A/γ que reporta la celda de saturación. Vida media del efecto: ln(0,5)/ln(θ), 0,6 semanas con θ = 0,3; 1 semana con θ = 0,5; 1,9 semanas con θ = 0,7. La posición en la curva describe la transformación, no el retorno: estar cerca del techo no obliga a recortar, pero sí indica que un peso </a:t>
+            </a:r>
+            <a:r>
+              <a:rPr lang="en-US" dirty="0" err="1"/>
+              <a:t>adicional</a:t>
+            </a:r>
+            <a:r>
+              <a:rPr lang="en-US" dirty="0"/>
+              <a:t> </a:t>
+            </a:r>
+            <a:r>
+              <a:rPr lang="en-US" dirty="0" err="1"/>
+              <a:t>probablemente</a:t>
+            </a:r>
+            <a:r>
+              <a:rPr lang="en-US" dirty="0"/>
+              <a:t> </a:t>
+            </a:r>
+            <a:r>
+              <a:rPr lang="en-US" dirty="0" err="1"/>
+              <a:t>rinda</a:t>
+            </a:r>
+            <a:r>
+              <a:rPr lang="en-US" dirty="0"/>
+              <a:t> poco. La </a:t>
+            </a:r>
+            <a:r>
+              <a:rPr lang="en-US" dirty="0" err="1"/>
+              <a:t>decisión</a:t>
+            </a:r>
+            <a:r>
+              <a:rPr lang="en-US" dirty="0"/>
+              <a:t> </a:t>
+            </a:r>
+            <a:r>
+              <a:rPr lang="en-US" dirty="0" err="1"/>
+              <a:t>requiere</a:t>
+            </a:r>
+            <a:r>
+              <a:rPr lang="en-US" dirty="0"/>
+              <a:t> </a:t>
+            </a:r>
+            <a:r>
+              <a:rPr lang="en-US" dirty="0" err="1"/>
+              <a:t>además</a:t>
+            </a:r>
+            <a:r>
+              <a:rPr lang="en-US" dirty="0"/>
+              <a:t> el </a:t>
+            </a:r>
+            <a:r>
+              <a:rPr lang="en-US" dirty="0" err="1"/>
+              <a:t>coeficiente</a:t>
+            </a:r>
+            <a:r>
+              <a:rPr lang="en-US" dirty="0"/>
+              <a:t>, </a:t>
+            </a:r>
+            <a:r>
+              <a:rPr lang="en-US" dirty="0" err="1"/>
+              <a:t>su</a:t>
+            </a:r>
+            <a:r>
+              <a:rPr lang="en-US" dirty="0"/>
+              <a:t> </a:t>
+            </a:r>
+            <a:r>
+              <a:rPr lang="en-US" dirty="0" err="1"/>
+              <a:t>incertidumbre</a:t>
+            </a:r>
+            <a:r>
+              <a:rPr lang="en-US" dirty="0"/>
+              <a:t> y el </a:t>
+            </a:r>
+            <a:r>
+              <a:rPr lang="en-US" dirty="0" err="1"/>
+              <a:t>costo</a:t>
+            </a:r>
+            <a:r>
+              <a:rPr lang="en-US" dirty="0"/>
+              <a:t>. Instagram y radio </a:t>
+            </a:r>
+            <a:r>
+              <a:rPr lang="en-US" dirty="0" err="1"/>
+              <a:t>aparecen</a:t>
+            </a:r>
+            <a:r>
+              <a:rPr lang="en-US" dirty="0"/>
+              <a:t> </a:t>
+            </a:r>
+            <a:r>
+              <a:rPr lang="en-US" dirty="0" err="1"/>
+              <a:t>saturados</a:t>
+            </a:r>
+            <a:r>
+              <a:rPr lang="en-US" dirty="0"/>
+              <a:t>, </a:t>
+            </a:r>
+            <a:r>
+              <a:rPr lang="en-US" dirty="0" err="1"/>
+              <a:t>pero</a:t>
+            </a:r>
+            <a:r>
+              <a:rPr lang="en-US" dirty="0"/>
+              <a:t> </a:t>
+            </a:r>
+            <a:r>
+              <a:rPr lang="en-US" dirty="0" err="1"/>
+              <a:t>su</a:t>
+            </a:r>
+            <a:r>
+              <a:rPr lang="en-US" dirty="0"/>
+              <a:t> </a:t>
+            </a:r>
+            <a:r>
+              <a:rPr lang="en-US" dirty="0" err="1"/>
+              <a:t>coeficiente</a:t>
+            </a:r>
+            <a:r>
+              <a:rPr lang="en-US" dirty="0"/>
+              <a:t> no es </a:t>
+            </a:r>
+            <a:r>
+              <a:rPr lang="en-US" dirty="0" err="1"/>
+              <a:t>significativo</a:t>
+            </a:r>
+            <a:r>
+              <a:rPr lang="en-US" dirty="0"/>
+              <a:t>.</a:t>
+            </a:r>
+          </a:p>
+          <a:p>
+            <a:endParaRPr lang="en-US" dirty="0"/>
+          </a:p>
+          <a:p>
+            <a:endParaRPr lang="en-US" dirty="0"/>
+          </a:p>
+          <a:p>
+            <a:r>
+              <a:rPr lang="en-US" dirty="0"/>
+              <a:t>A la </a:t>
+            </a:r>
+            <a:r>
+              <a:rPr lang="en-US" dirty="0" err="1"/>
+              <a:t>izquierda</a:t>
+            </a:r>
+            <a:r>
+              <a:rPr lang="en-US" dirty="0"/>
+              <a:t> </a:t>
+            </a:r>
+            <a:r>
+              <a:rPr lang="en-US" dirty="0" err="1"/>
+              <a:t>vemos</a:t>
+            </a:r>
+            <a:r>
+              <a:rPr lang="en-US" dirty="0"/>
+              <a:t> </a:t>
+            </a:r>
+            <a:r>
+              <a:rPr lang="en-US" dirty="0" err="1"/>
+              <a:t>cuánto</a:t>
+            </a:r>
+            <a:r>
+              <a:rPr lang="en-US" dirty="0"/>
+              <a:t> dura el </a:t>
+            </a:r>
+            <a:r>
+              <a:rPr lang="en-US" dirty="0" err="1"/>
+              <a:t>recuerdo</a:t>
+            </a:r>
+            <a:r>
+              <a:rPr lang="en-US" dirty="0"/>
+              <a:t> de </a:t>
+            </a:r>
+            <a:r>
+              <a:rPr lang="en-US" dirty="0" err="1"/>
+              <a:t>una</a:t>
+            </a:r>
+            <a:r>
+              <a:rPr lang="en-US" dirty="0"/>
+              <a:t> </a:t>
+            </a:r>
+            <a:r>
+              <a:rPr lang="en-US" dirty="0" err="1"/>
+              <a:t>campaña</a:t>
+            </a:r>
+            <a:r>
+              <a:rPr lang="en-US" dirty="0"/>
+              <a:t>: </a:t>
+            </a:r>
+            <a:r>
+              <a:rPr lang="en-US" dirty="0" err="1"/>
+              <a:t>en</a:t>
+            </a:r>
+            <a:r>
+              <a:rPr lang="en-US" dirty="0"/>
+              <a:t> Facebook, YouTube y TV local se </a:t>
+            </a:r>
+            <a:r>
+              <a:rPr lang="en-US" dirty="0" err="1"/>
+              <a:t>apaga</a:t>
+            </a:r>
+            <a:r>
+              <a:rPr lang="en-US" dirty="0"/>
+              <a:t> </a:t>
+            </a:r>
+            <a:r>
+              <a:rPr lang="en-US" dirty="0" err="1"/>
+              <a:t>rápido</a:t>
+            </a:r>
+            <a:r>
+              <a:rPr lang="en-US" dirty="0"/>
+              <a:t>, </a:t>
+            </a:r>
+            <a:r>
+              <a:rPr lang="en-US" dirty="0" err="1"/>
+              <a:t>en</a:t>
+            </a:r>
+            <a:r>
+              <a:rPr lang="en-US" dirty="0"/>
+              <a:t> Instagram y radio dura </a:t>
+            </a:r>
+            <a:r>
+              <a:rPr lang="en-US" dirty="0" err="1"/>
+              <a:t>más</a:t>
+            </a:r>
+            <a:r>
+              <a:rPr lang="en-US" dirty="0"/>
+              <a:t>. A la </a:t>
+            </a:r>
+            <a:r>
+              <a:rPr lang="en-US" dirty="0" err="1"/>
+              <a:t>derecha</a:t>
+            </a:r>
+            <a:r>
+              <a:rPr lang="en-US" dirty="0"/>
+              <a:t>, </a:t>
+            </a:r>
+            <a:r>
+              <a:rPr lang="en-US" dirty="0" err="1"/>
+              <a:t>qué</a:t>
+            </a:r>
+            <a:r>
+              <a:rPr lang="en-US" dirty="0"/>
+              <a:t> tan </a:t>
+            </a:r>
+            <a:r>
+              <a:rPr lang="en-US" dirty="0" err="1"/>
+              <a:t>lleno</a:t>
+            </a:r>
+            <a:r>
+              <a:rPr lang="en-US" dirty="0"/>
+              <a:t> </a:t>
+            </a:r>
+            <a:r>
+              <a:rPr lang="en-US" dirty="0" err="1"/>
+              <a:t>está</a:t>
+            </a:r>
+            <a:r>
+              <a:rPr lang="en-US" dirty="0"/>
+              <a:t> el </a:t>
+            </a:r>
+            <a:r>
+              <a:rPr lang="en-US" dirty="0" err="1"/>
+              <a:t>vaso</a:t>
+            </a:r>
+            <a:r>
+              <a:rPr lang="en-US" dirty="0"/>
+              <a:t> de </a:t>
+            </a:r>
+            <a:r>
+              <a:rPr lang="en-US" dirty="0" err="1"/>
+              <a:t>cada</a:t>
+            </a:r>
+            <a:r>
+              <a:rPr lang="en-US" dirty="0"/>
+              <a:t> canal. Facebook </a:t>
+            </a:r>
+            <a:r>
+              <a:rPr lang="en-US" dirty="0" err="1"/>
+              <a:t>ya</a:t>
+            </a:r>
+            <a:r>
+              <a:rPr lang="en-US" dirty="0"/>
+              <a:t> </a:t>
+            </a:r>
+            <a:r>
+              <a:rPr lang="en-US" dirty="0" err="1"/>
+              <a:t>está</a:t>
+            </a:r>
+            <a:r>
+              <a:rPr lang="en-US" dirty="0"/>
+              <a:t> </a:t>
+            </a:r>
+            <a:r>
+              <a:rPr lang="en-US" dirty="0" err="1"/>
+              <a:t>casi</a:t>
+            </a:r>
+            <a:r>
+              <a:rPr lang="en-US" dirty="0"/>
+              <a:t> </a:t>
+            </a:r>
+            <a:r>
+              <a:rPr lang="en-US" dirty="0" err="1"/>
+              <a:t>lleno</a:t>
+            </a:r>
+            <a:r>
+              <a:rPr lang="en-US" dirty="0"/>
+              <a:t>: </a:t>
+            </a:r>
+            <a:r>
+              <a:rPr lang="en-US" dirty="0" err="1"/>
+              <a:t>más</a:t>
+            </a:r>
+            <a:r>
+              <a:rPr lang="en-US" dirty="0"/>
+              <a:t> </a:t>
+            </a:r>
+            <a:r>
+              <a:rPr lang="en-US" dirty="0" err="1"/>
+              <a:t>inversión</a:t>
+            </a:r>
+            <a:r>
+              <a:rPr lang="en-US" dirty="0"/>
+              <a:t> ahí </a:t>
+            </a:r>
+            <a:r>
+              <a:rPr lang="en-US" dirty="0" err="1"/>
+              <a:t>rinde</a:t>
+            </a:r>
+            <a:r>
+              <a:rPr lang="en-US" dirty="0"/>
+              <a:t> poco. TV local, </a:t>
+            </a:r>
+            <a:r>
+              <a:rPr lang="en-US" dirty="0" err="1"/>
+              <a:t>en</a:t>
+            </a:r>
+            <a:r>
+              <a:rPr lang="en-US" dirty="0"/>
+              <a:t> </a:t>
+            </a:r>
+            <a:r>
+              <a:rPr lang="en-US" dirty="0" err="1"/>
+              <a:t>cambio</a:t>
+            </a:r>
+            <a:r>
+              <a:rPr lang="en-US" dirty="0"/>
+              <a:t>, </a:t>
+            </a:r>
+            <a:r>
+              <a:rPr lang="en-US" dirty="0" err="1"/>
+              <a:t>está</a:t>
+            </a:r>
+            <a:r>
+              <a:rPr lang="en-US" dirty="0"/>
+              <a:t> al 30 % y con </a:t>
+            </a:r>
+            <a:r>
+              <a:rPr lang="en-US" dirty="0" err="1"/>
+              <a:t>evidencia</a:t>
+            </a:r>
+            <a:r>
+              <a:rPr lang="en-US" dirty="0"/>
+              <a:t> de </a:t>
+            </a:r>
+            <a:r>
+              <a:rPr lang="en-US" dirty="0" err="1"/>
+              <a:t>que</a:t>
+            </a:r>
+            <a:r>
+              <a:rPr lang="en-US" dirty="0"/>
+              <a:t> </a:t>
+            </a:r>
+            <a:r>
+              <a:rPr lang="en-US" dirty="0" err="1"/>
+              <a:t>funciona</a:t>
+            </a:r>
+            <a:r>
+              <a:rPr lang="en-US" dirty="0"/>
+              <a:t>. Por </a:t>
+            </a:r>
+            <a:r>
+              <a:rPr lang="en-US" dirty="0" err="1"/>
+              <a:t>eso</a:t>
+            </a:r>
+            <a:r>
+              <a:rPr lang="en-US" dirty="0"/>
+              <a:t> es el primer </a:t>
+            </a:r>
+            <a:r>
+              <a:rPr lang="en-US" dirty="0" err="1"/>
+              <a:t>candidato</a:t>
+            </a:r>
+            <a:r>
+              <a:rPr lang="en-US" dirty="0"/>
+              <a:t> para </a:t>
+            </a:r>
+            <a:r>
+              <a:rPr lang="en-US" dirty="0" err="1"/>
+              <a:t>probar</a:t>
+            </a:r>
+            <a:r>
+              <a:rPr lang="en-US" dirty="0"/>
+              <a:t> </a:t>
+            </a:r>
+            <a:r>
+              <a:rPr lang="en-US" dirty="0" err="1"/>
+              <a:t>más</a:t>
+            </a:r>
+            <a:r>
+              <a:rPr lang="en-US" dirty="0"/>
+              <a:t> </a:t>
+            </a:r>
+            <a:r>
+              <a:rPr lang="en-US" dirty="0" err="1"/>
+              <a:t>inversión</a:t>
+            </a:r>
+            <a:endParaRPr lang="en-US" dirty="0"/>
+          </a:p>
+          <a:p>
+            <a:endParaRPr lang="en-US" dirty="0"/>
+          </a:p>
+          <a:p>
+            <a:endParaRPr lang="en-US" dirty="0"/>
+          </a:p>
+          <a:p>
+            <a:pPr lvl="0" rtl="0"/>
+            <a:r>
+              <a:rPr lang="en-US" dirty="0" err="1"/>
+              <a:t>Todas</a:t>
+            </a:r>
+            <a:r>
+              <a:rPr lang="en-US" dirty="0"/>
+              <a:t> las </a:t>
+            </a:r>
+            <a:r>
+              <a:rPr lang="en-US" dirty="0" err="1"/>
+              <a:t>líneas</a:t>
+            </a:r>
+            <a:r>
+              <a:rPr lang="en-US" dirty="0"/>
+              <a:t> </a:t>
+            </a:r>
+            <a:r>
+              <a:rPr lang="en-US" dirty="0" err="1"/>
+              <a:t>arrancan</a:t>
+            </a:r>
+            <a:r>
+              <a:rPr lang="en-US" dirty="0"/>
+              <a:t> </a:t>
+            </a:r>
+            <a:r>
+              <a:rPr lang="en-US" dirty="0" err="1"/>
+              <a:t>en</a:t>
+            </a:r>
+            <a:r>
+              <a:rPr lang="en-US" dirty="0"/>
+              <a:t> 100 %: es la </a:t>
+            </a:r>
+            <a:r>
+              <a:rPr lang="en-US" dirty="0" err="1"/>
+              <a:t>fuerza</a:t>
+            </a:r>
+            <a:r>
+              <a:rPr lang="en-US" dirty="0"/>
+              <a:t> de la </a:t>
+            </a:r>
+            <a:r>
+              <a:rPr lang="en-US" dirty="0" err="1"/>
+              <a:t>campaña</a:t>
+            </a:r>
+            <a:r>
+              <a:rPr lang="en-US" dirty="0"/>
+              <a:t> la </a:t>
+            </a:r>
+            <a:r>
+              <a:rPr lang="en-US" dirty="0" err="1"/>
+              <a:t>semana</a:t>
+            </a:r>
+            <a:r>
+              <a:rPr lang="en-US" dirty="0"/>
+              <a:t> </a:t>
+            </a:r>
+            <a:r>
+              <a:rPr lang="en-US" dirty="0" err="1"/>
+              <a:t>en</a:t>
+            </a:r>
+            <a:r>
+              <a:rPr lang="en-US" dirty="0"/>
+              <a:t> </a:t>
+            </a:r>
+            <a:r>
+              <a:rPr lang="en-US" dirty="0" err="1"/>
+              <a:t>que</a:t>
+            </a:r>
+            <a:r>
+              <a:rPr lang="en-US" dirty="0"/>
+              <a:t> sale al </a:t>
+            </a:r>
+            <a:r>
+              <a:rPr lang="en-US" dirty="0" err="1"/>
+              <a:t>aire</a:t>
+            </a:r>
+            <a:r>
+              <a:rPr lang="en-US" dirty="0"/>
+              <a:t>.</a:t>
+            </a:r>
+          </a:p>
+          <a:p>
+            <a:pPr lvl="0" rtl="0"/>
+            <a:endParaRPr lang="en-US" dirty="0"/>
+          </a:p>
+          <a:p>
+            <a:pPr lvl="0" rtl="0"/>
+            <a:r>
+              <a:rPr lang="en-US" dirty="0"/>
+              <a:t>Cada </a:t>
+            </a:r>
+            <a:r>
+              <a:rPr lang="en-US" dirty="0" err="1"/>
+              <a:t>línea</a:t>
+            </a:r>
+            <a:r>
+              <a:rPr lang="en-US" dirty="0"/>
+              <a:t> </a:t>
+            </a:r>
+            <a:r>
+              <a:rPr lang="en-US" dirty="0" err="1"/>
+              <a:t>muestra</a:t>
+            </a:r>
+            <a:r>
+              <a:rPr lang="en-US" dirty="0"/>
+              <a:t> </a:t>
+            </a:r>
+            <a:r>
+              <a:rPr lang="en-US" dirty="0" err="1"/>
+              <a:t>cuánto</a:t>
+            </a:r>
+            <a:r>
+              <a:rPr lang="en-US" dirty="0"/>
+              <a:t> de </a:t>
+            </a:r>
+            <a:r>
+              <a:rPr lang="en-US" dirty="0" err="1"/>
+              <a:t>esa</a:t>
+            </a:r>
+            <a:r>
+              <a:rPr lang="en-US" dirty="0"/>
+              <a:t> </a:t>
+            </a:r>
+            <a:r>
+              <a:rPr lang="en-US" dirty="0" err="1"/>
+              <a:t>fuerza</a:t>
+            </a:r>
+            <a:r>
+              <a:rPr lang="en-US" dirty="0"/>
+              <a:t> </a:t>
+            </a:r>
+            <a:r>
+              <a:rPr lang="en-US" dirty="0" err="1"/>
+              <a:t>sigue</a:t>
+            </a:r>
+            <a:r>
+              <a:rPr lang="en-US" dirty="0"/>
+              <a:t> viva </a:t>
+            </a:r>
+            <a:r>
+              <a:rPr lang="en-US" dirty="0" err="1"/>
+              <a:t>en</a:t>
+            </a:r>
+            <a:r>
+              <a:rPr lang="en-US" dirty="0"/>
+              <a:t> las </a:t>
+            </a:r>
+            <a:r>
+              <a:rPr lang="en-US" dirty="0" err="1"/>
+              <a:t>semanas</a:t>
+            </a:r>
+            <a:r>
+              <a:rPr lang="en-US" dirty="0"/>
+              <a:t> </a:t>
+            </a:r>
+            <a:r>
+              <a:rPr lang="en-US" dirty="0" err="1"/>
+              <a:t>siguientes</a:t>
+            </a:r>
+            <a:r>
+              <a:rPr lang="en-US" dirty="0"/>
+              <a:t>.</a:t>
+            </a:r>
+          </a:p>
+          <a:p>
+            <a:pPr lvl="0" rtl="0"/>
+            <a:endParaRPr lang="en-US" b="1" dirty="0"/>
+          </a:p>
+          <a:p>
+            <a:pPr lvl="0" rtl="0"/>
+            <a:r>
+              <a:rPr lang="en-US" b="1" dirty="0" err="1"/>
+              <a:t>Cuanto</a:t>
+            </a:r>
+            <a:r>
+              <a:rPr lang="en-US" b="1" dirty="0"/>
+              <a:t> </a:t>
+            </a:r>
+            <a:r>
+              <a:rPr lang="en-US" b="1" dirty="0" err="1"/>
+              <a:t>más</a:t>
+            </a:r>
+            <a:r>
+              <a:rPr lang="en-US" b="1" dirty="0"/>
+              <a:t> </a:t>
+            </a:r>
+            <a:r>
+              <a:rPr lang="en-US" b="1" dirty="0" err="1"/>
+              <a:t>rápido</a:t>
+            </a:r>
+            <a:r>
+              <a:rPr lang="en-US" b="1" dirty="0"/>
+              <a:t> </a:t>
+            </a:r>
+            <a:r>
+              <a:rPr lang="en-US" b="1" dirty="0" err="1"/>
+              <a:t>cae</a:t>
+            </a:r>
+            <a:r>
+              <a:rPr lang="en-US" b="1" dirty="0"/>
+              <a:t> la </a:t>
+            </a:r>
+            <a:r>
+              <a:rPr lang="en-US" b="1" dirty="0" err="1"/>
+              <a:t>línea</a:t>
+            </a:r>
+            <a:r>
+              <a:rPr lang="en-US" b="1" dirty="0"/>
+              <a:t>, </a:t>
+            </a:r>
+            <a:r>
+              <a:rPr lang="en-US" b="1" dirty="0" err="1"/>
+              <a:t>más</a:t>
+            </a:r>
+            <a:r>
+              <a:rPr lang="en-US" b="1" dirty="0"/>
+              <a:t> </a:t>
+            </a:r>
+            <a:r>
+              <a:rPr lang="en-US" b="1" dirty="0" err="1"/>
+              <a:t>corta</a:t>
+            </a:r>
+            <a:r>
+              <a:rPr lang="en-US" b="1" dirty="0"/>
+              <a:t> es la memoria del canal.</a:t>
+            </a:r>
+            <a:endParaRPr lang="en-US" dirty="0"/>
+          </a:p>
+          <a:p>
+            <a:pPr rtl="0"/>
+            <a:endParaRPr lang="en-US" b="1" dirty="0"/>
+          </a:p>
+          <a:p>
+            <a:pPr rtl="0"/>
+            <a:r>
+              <a:rPr lang="en-US" b="1" dirty="0" err="1"/>
+              <a:t>Qué</a:t>
+            </a:r>
+            <a:r>
+              <a:rPr lang="en-US" b="1" dirty="0"/>
+              <a:t> dice:</a:t>
+            </a:r>
+            <a:endParaRPr lang="en-US" dirty="0"/>
+          </a:p>
+          <a:p>
+            <a:pPr lvl="0" rtl="0"/>
+            <a:r>
+              <a:rPr lang="en-US" b="1" dirty="0"/>
+              <a:t>Facebook, YouTube, TV local y video digital</a:t>
+            </a:r>
+            <a:r>
+              <a:rPr lang="en-US" dirty="0"/>
+              <a:t> (</a:t>
+            </a:r>
+            <a:r>
+              <a:rPr lang="en-US" dirty="0" err="1"/>
+              <a:t>línea</a:t>
+            </a:r>
+            <a:r>
+              <a:rPr lang="en-US" dirty="0"/>
+              <a:t> gris): el </a:t>
+            </a:r>
+            <a:r>
+              <a:rPr lang="en-US" dirty="0" err="1"/>
+              <a:t>efecto</a:t>
+            </a:r>
+            <a:r>
+              <a:rPr lang="en-US" dirty="0"/>
+              <a:t> se </a:t>
+            </a:r>
+            <a:r>
+              <a:rPr lang="en-US" dirty="0" err="1"/>
+              <a:t>apaga</a:t>
+            </a:r>
+            <a:r>
+              <a:rPr lang="en-US" dirty="0"/>
+              <a:t> </a:t>
+            </a:r>
+            <a:r>
+              <a:rPr lang="en-US" dirty="0" err="1"/>
+              <a:t>rápido</a:t>
+            </a:r>
+            <a:r>
+              <a:rPr lang="en-US" dirty="0"/>
+              <a:t>. En </a:t>
+            </a:r>
+            <a:r>
+              <a:rPr lang="en-US" dirty="0" err="1"/>
+              <a:t>menos</a:t>
+            </a:r>
+            <a:r>
+              <a:rPr lang="en-US" dirty="0"/>
+              <a:t> de </a:t>
+            </a:r>
+            <a:r>
+              <a:rPr lang="en-US" dirty="0" err="1"/>
+              <a:t>una</a:t>
+            </a:r>
+            <a:r>
+              <a:rPr lang="en-US" dirty="0"/>
+              <a:t> </a:t>
+            </a:r>
+            <a:r>
+              <a:rPr lang="en-US" dirty="0" err="1"/>
+              <a:t>semana</a:t>
+            </a:r>
+            <a:r>
+              <a:rPr lang="en-US" dirty="0"/>
+              <a:t> </a:t>
+            </a:r>
+            <a:r>
+              <a:rPr lang="en-US" dirty="0" err="1"/>
+              <a:t>ya</a:t>
+            </a:r>
+            <a:r>
+              <a:rPr lang="en-US" dirty="0"/>
+              <a:t> </a:t>
+            </a:r>
+            <a:r>
+              <a:rPr lang="en-US" dirty="0" err="1"/>
+              <a:t>perdió</a:t>
+            </a:r>
+            <a:r>
+              <a:rPr lang="en-US" dirty="0"/>
+              <a:t> la </a:t>
+            </a:r>
+            <a:r>
+              <a:rPr lang="en-US" dirty="0" err="1"/>
+              <a:t>mitad</a:t>
+            </a:r>
+            <a:r>
+              <a:rPr lang="en-US" dirty="0"/>
+              <a:t>. Son canales de </a:t>
+            </a:r>
+            <a:r>
+              <a:rPr lang="en-US" dirty="0" err="1"/>
+              <a:t>impacto</a:t>
+            </a:r>
+            <a:r>
+              <a:rPr lang="en-US" dirty="0"/>
+              <a:t> </a:t>
+            </a:r>
+            <a:r>
+              <a:rPr lang="en-US" dirty="0" err="1"/>
+              <a:t>inmediato</a:t>
+            </a:r>
+            <a:r>
+              <a:rPr lang="en-US" dirty="0"/>
+              <a:t>.</a:t>
+            </a:r>
+          </a:p>
+          <a:p>
+            <a:pPr lvl="0" rtl="0"/>
+            <a:r>
+              <a:rPr lang="en-US" b="1" dirty="0"/>
+              <a:t>TV </a:t>
+            </a:r>
+            <a:r>
+              <a:rPr lang="en-US" b="1" dirty="0" err="1"/>
+              <a:t>abierta</a:t>
+            </a:r>
+            <a:r>
+              <a:rPr lang="en-US" b="1" dirty="0"/>
+              <a:t> y TV de </a:t>
+            </a:r>
+            <a:r>
+              <a:rPr lang="en-US" b="1" dirty="0" err="1"/>
+              <a:t>pago</a:t>
+            </a:r>
+            <a:r>
+              <a:rPr lang="en-US" dirty="0"/>
+              <a:t> (</a:t>
+            </a:r>
+            <a:r>
+              <a:rPr lang="en-US" dirty="0" err="1"/>
+              <a:t>línea</a:t>
+            </a:r>
+            <a:r>
+              <a:rPr lang="en-US" dirty="0"/>
+              <a:t> </a:t>
+            </a:r>
+            <a:r>
+              <a:rPr lang="en-US" dirty="0" err="1"/>
+              <a:t>azul</a:t>
+            </a:r>
+            <a:r>
+              <a:rPr lang="en-US" dirty="0"/>
+              <a:t>): la </a:t>
+            </a:r>
+            <a:r>
+              <a:rPr lang="en-US" dirty="0" err="1"/>
+              <a:t>mitad</a:t>
+            </a:r>
+            <a:r>
+              <a:rPr lang="en-US" dirty="0"/>
+              <a:t> del </a:t>
+            </a:r>
+            <a:r>
+              <a:rPr lang="en-US" dirty="0" err="1"/>
+              <a:t>efecto</a:t>
+            </a:r>
+            <a:r>
+              <a:rPr lang="en-US" dirty="0"/>
+              <a:t> dura </a:t>
+            </a:r>
+            <a:r>
+              <a:rPr lang="en-US" dirty="0" err="1"/>
+              <a:t>alrededor</a:t>
+            </a:r>
+            <a:r>
+              <a:rPr lang="en-US" dirty="0"/>
+              <a:t> de </a:t>
+            </a:r>
+            <a:r>
+              <a:rPr lang="en-US" dirty="0" err="1"/>
+              <a:t>una</a:t>
+            </a:r>
+            <a:r>
+              <a:rPr lang="en-US" dirty="0"/>
+              <a:t> </a:t>
+            </a:r>
+            <a:r>
+              <a:rPr lang="en-US" dirty="0" err="1"/>
+              <a:t>semana</a:t>
+            </a:r>
+            <a:r>
+              <a:rPr lang="en-US" dirty="0"/>
+              <a:t>.</a:t>
+            </a:r>
+          </a:p>
+          <a:p>
+            <a:pPr lvl="0" rtl="0"/>
+            <a:r>
+              <a:rPr lang="en-US" b="1" dirty="0"/>
+              <a:t>Instagram y radio</a:t>
+            </a:r>
+            <a:r>
+              <a:rPr lang="en-US" dirty="0"/>
+              <a:t> (</a:t>
+            </a:r>
+            <a:r>
+              <a:rPr lang="en-US" dirty="0" err="1"/>
+              <a:t>línea</a:t>
+            </a:r>
+            <a:r>
+              <a:rPr lang="en-US" dirty="0"/>
+              <a:t> </a:t>
+            </a:r>
+            <a:r>
+              <a:rPr lang="en-US" dirty="0" err="1"/>
+              <a:t>dorada</a:t>
+            </a:r>
+            <a:r>
+              <a:rPr lang="en-US" dirty="0"/>
+              <a:t>): el </a:t>
+            </a:r>
+            <a:r>
+              <a:rPr lang="en-US" dirty="0" err="1"/>
+              <a:t>recuerdo</a:t>
+            </a:r>
+            <a:r>
+              <a:rPr lang="en-US" dirty="0"/>
+              <a:t> dura </a:t>
+            </a:r>
+            <a:r>
+              <a:rPr lang="en-US" dirty="0" err="1"/>
+              <a:t>más</a:t>
+            </a:r>
+            <a:r>
+              <a:rPr lang="en-US" dirty="0"/>
+              <a:t>. </a:t>
+            </a:r>
+            <a:r>
+              <a:rPr lang="en-US" dirty="0" err="1"/>
+              <a:t>Tardan</a:t>
+            </a:r>
+            <a:r>
+              <a:rPr lang="en-US" dirty="0"/>
+              <a:t> </a:t>
+            </a:r>
+            <a:r>
+              <a:rPr lang="en-US" dirty="0" err="1"/>
+              <a:t>unas</a:t>
+            </a:r>
+            <a:r>
+              <a:rPr lang="en-US" dirty="0"/>
+              <a:t> dos </a:t>
+            </a:r>
+            <a:r>
+              <a:rPr lang="en-US" dirty="0" err="1"/>
+              <a:t>semanas</a:t>
+            </a:r>
+            <a:r>
+              <a:rPr lang="en-US" dirty="0"/>
+              <a:t> </a:t>
+            </a:r>
+            <a:r>
+              <a:rPr lang="en-US" dirty="0" err="1"/>
+              <a:t>en</a:t>
+            </a:r>
+            <a:r>
+              <a:rPr lang="en-US" dirty="0"/>
+              <a:t> </a:t>
+            </a:r>
+            <a:r>
+              <a:rPr lang="en-US" dirty="0" err="1"/>
+              <a:t>perder</a:t>
+            </a:r>
+            <a:r>
+              <a:rPr lang="en-US" dirty="0"/>
+              <a:t> la </a:t>
+            </a:r>
+            <a:r>
+              <a:rPr lang="en-US" dirty="0" err="1"/>
+              <a:t>mitad</a:t>
+            </a:r>
+            <a:r>
+              <a:rPr lang="en-US" dirty="0"/>
+              <a:t> y al </a:t>
+            </a:r>
+            <a:r>
+              <a:rPr lang="en-US" dirty="0" err="1"/>
+              <a:t>cabo</a:t>
+            </a:r>
+            <a:r>
+              <a:rPr lang="en-US" dirty="0"/>
+              <a:t> de un </a:t>
+            </a:r>
+            <a:r>
+              <a:rPr lang="en-US" dirty="0" err="1"/>
+              <a:t>mes</a:t>
+            </a:r>
+            <a:r>
+              <a:rPr lang="en-US" dirty="0"/>
+              <a:t> </a:t>
+            </a:r>
+            <a:r>
+              <a:rPr lang="en-US" dirty="0" err="1"/>
+              <a:t>todavía</a:t>
+            </a:r>
+            <a:r>
+              <a:rPr lang="en-US" dirty="0"/>
+              <a:t> </a:t>
+            </a:r>
+            <a:r>
+              <a:rPr lang="en-US" dirty="0" err="1"/>
+              <a:t>queda</a:t>
+            </a:r>
+            <a:r>
+              <a:rPr lang="en-US" dirty="0"/>
+              <a:t> </a:t>
+            </a:r>
+            <a:r>
+              <a:rPr lang="en-US" dirty="0" err="1"/>
+              <a:t>una</a:t>
+            </a:r>
+            <a:r>
+              <a:rPr lang="en-US" dirty="0"/>
+              <a:t> </a:t>
+            </a:r>
+            <a:r>
+              <a:rPr lang="en-US" dirty="0" err="1"/>
+              <a:t>cuarta</a:t>
+            </a:r>
+            <a:r>
+              <a:rPr lang="en-US" dirty="0"/>
+              <a:t> </a:t>
+            </a:r>
+            <a:r>
+              <a:rPr lang="en-US" dirty="0" err="1"/>
+              <a:t>parte</a:t>
+            </a:r>
+            <a:r>
+              <a:rPr lang="en-US" dirty="0"/>
+              <a:t>.</a:t>
+            </a:r>
+          </a:p>
+          <a:p>
+            <a:pPr rtl="0"/>
+            <a:r>
+              <a:rPr lang="en-US" b="1" dirty="0"/>
+              <a:t>Para </a:t>
+            </a:r>
+            <a:r>
+              <a:rPr lang="en-US" b="1" dirty="0" err="1"/>
+              <a:t>qué</a:t>
+            </a:r>
+            <a:r>
+              <a:rPr lang="en-US" b="1" dirty="0"/>
+              <a:t> </a:t>
+            </a:r>
+            <a:r>
+              <a:rPr lang="en-US" b="1" dirty="0" err="1"/>
+              <a:t>sirve</a:t>
+            </a:r>
+            <a:r>
+              <a:rPr lang="en-US" b="1" dirty="0"/>
+              <a:t>:</a:t>
+            </a:r>
+            <a:r>
+              <a:rPr lang="en-US" dirty="0"/>
+              <a:t> </a:t>
+            </a:r>
+            <a:r>
+              <a:rPr lang="en-US" dirty="0" err="1"/>
+              <a:t>los</a:t>
+            </a:r>
+            <a:r>
+              <a:rPr lang="en-US" dirty="0"/>
+              <a:t> canales de memoria </a:t>
+            </a:r>
+            <a:r>
+              <a:rPr lang="en-US" dirty="0" err="1"/>
+              <a:t>corta</a:t>
+            </a:r>
+            <a:r>
+              <a:rPr lang="en-US" dirty="0"/>
+              <a:t> </a:t>
+            </a:r>
+            <a:r>
+              <a:rPr lang="en-US" dirty="0" err="1"/>
+              <a:t>necesitan</a:t>
+            </a:r>
+            <a:r>
+              <a:rPr lang="en-US" dirty="0"/>
+              <a:t> </a:t>
+            </a:r>
+            <a:r>
+              <a:rPr lang="en-US" dirty="0" err="1"/>
+              <a:t>presencia</a:t>
+            </a:r>
+            <a:r>
+              <a:rPr lang="en-US" dirty="0"/>
+              <a:t> </a:t>
+            </a:r>
+            <a:r>
+              <a:rPr lang="en-US" dirty="0" err="1"/>
+              <a:t>más</a:t>
+            </a:r>
+            <a:r>
+              <a:rPr lang="en-US" dirty="0"/>
+              <a:t> continua; </a:t>
+            </a:r>
+            <a:r>
+              <a:rPr lang="en-US" dirty="0" err="1"/>
+              <a:t>los</a:t>
+            </a:r>
+            <a:r>
+              <a:rPr lang="en-US" dirty="0"/>
+              <a:t> de memoria </a:t>
+            </a:r>
+            <a:r>
+              <a:rPr lang="en-US" dirty="0" err="1"/>
+              <a:t>larga</a:t>
+            </a:r>
+            <a:r>
+              <a:rPr lang="en-US" dirty="0"/>
+              <a:t> </a:t>
+            </a:r>
+            <a:r>
+              <a:rPr lang="en-US" dirty="0" err="1"/>
+              <a:t>permiten</a:t>
+            </a:r>
+            <a:r>
+              <a:rPr lang="en-US" dirty="0"/>
+              <a:t> </a:t>
+            </a:r>
+            <a:r>
+              <a:rPr lang="en-US" dirty="0" err="1"/>
+              <a:t>espaciar</a:t>
+            </a:r>
+            <a:r>
+              <a:rPr lang="en-US" dirty="0"/>
+              <a:t> </a:t>
+            </a:r>
+            <a:r>
+              <a:rPr lang="en-US" dirty="0" err="1"/>
+              <a:t>más</a:t>
+            </a:r>
+            <a:r>
+              <a:rPr lang="en-US" dirty="0"/>
+              <a:t> las </a:t>
+            </a:r>
+            <a:r>
+              <a:rPr lang="en-US" dirty="0" err="1"/>
+              <a:t>campañas</a:t>
+            </a:r>
+            <a:r>
+              <a:rPr lang="en-US" dirty="0"/>
+              <a:t>.</a:t>
+            </a:r>
+          </a:p>
+          <a:p>
+            <a:pPr rtl="0"/>
+            <a:r>
+              <a:rPr lang="en-US" b="1" dirty="0" err="1"/>
+              <a:t>Gráficos</a:t>
+            </a:r>
+            <a:r>
+              <a:rPr lang="en-US" b="1" dirty="0"/>
+              <a:t> de la </a:t>
+            </a:r>
+            <a:r>
+              <a:rPr lang="en-US" b="1" dirty="0" err="1"/>
+              <a:t>derecha</a:t>
+            </a:r>
+            <a:r>
+              <a:rPr lang="en-US" b="1" dirty="0"/>
+              <a:t>: el </a:t>
+            </a:r>
+            <a:r>
+              <a:rPr lang="en-US" b="1" dirty="0" err="1"/>
+              <a:t>margen</a:t>
+            </a:r>
+            <a:r>
+              <a:rPr lang="en-US" b="1" dirty="0"/>
+              <a:t> para </a:t>
+            </a:r>
+            <a:r>
+              <a:rPr lang="en-US" b="1" dirty="0" err="1"/>
+              <a:t>crecer</a:t>
+            </a:r>
+            <a:endParaRPr lang="en-US" b="1" dirty="0"/>
+          </a:p>
+          <a:p>
+            <a:pPr rtl="0"/>
+            <a:r>
+              <a:rPr lang="en-US" b="1" dirty="0"/>
+              <a:t>La idea:</a:t>
+            </a:r>
+            <a:r>
+              <a:rPr lang="en-US" dirty="0"/>
+              <a:t> </a:t>
+            </a:r>
+            <a:r>
+              <a:rPr lang="en-US" dirty="0" err="1"/>
+              <a:t>invertir</a:t>
+            </a:r>
+            <a:r>
+              <a:rPr lang="en-US" dirty="0"/>
+              <a:t> </a:t>
+            </a:r>
+            <a:r>
+              <a:rPr lang="en-US" dirty="0" err="1"/>
+              <a:t>en</a:t>
+            </a:r>
+            <a:r>
+              <a:rPr lang="en-US" dirty="0"/>
+              <a:t> un canal es </a:t>
+            </a:r>
+            <a:r>
+              <a:rPr lang="en-US" dirty="0" err="1"/>
+              <a:t>como</a:t>
+            </a:r>
+            <a:r>
+              <a:rPr lang="en-US" dirty="0"/>
+              <a:t> </a:t>
+            </a:r>
+            <a:r>
+              <a:rPr lang="en-US" dirty="0" err="1"/>
+              <a:t>llenar</a:t>
+            </a:r>
+            <a:r>
+              <a:rPr lang="en-US" dirty="0"/>
+              <a:t> un </a:t>
+            </a:r>
+            <a:r>
+              <a:rPr lang="en-US" dirty="0" err="1"/>
+              <a:t>vaso</a:t>
+            </a:r>
+            <a:r>
+              <a:rPr lang="en-US" dirty="0"/>
+              <a:t>. Los primeros pesos </a:t>
+            </a:r>
+            <a:r>
+              <a:rPr lang="en-US" dirty="0" err="1"/>
+              <a:t>rinden</a:t>
+            </a:r>
+            <a:r>
+              <a:rPr lang="en-US" dirty="0"/>
+              <a:t> </a:t>
+            </a:r>
+            <a:r>
+              <a:rPr lang="en-US" dirty="0" err="1"/>
+              <a:t>mucho</a:t>
+            </a:r>
+            <a:r>
+              <a:rPr lang="en-US" dirty="0"/>
+              <a:t>, </a:t>
+            </a:r>
+            <a:r>
+              <a:rPr lang="en-US" dirty="0" err="1"/>
+              <a:t>pero</a:t>
+            </a:r>
+            <a:r>
+              <a:rPr lang="en-US" dirty="0"/>
+              <a:t> a </a:t>
+            </a:r>
+            <a:r>
+              <a:rPr lang="en-US" dirty="0" err="1"/>
+              <a:t>medida</a:t>
+            </a:r>
+            <a:r>
+              <a:rPr lang="en-US" dirty="0"/>
+              <a:t> </a:t>
+            </a:r>
+            <a:r>
+              <a:rPr lang="en-US" dirty="0" err="1"/>
+              <a:t>que</a:t>
+            </a:r>
+            <a:r>
+              <a:rPr lang="en-US" dirty="0"/>
+              <a:t> el </a:t>
+            </a:r>
+            <a:r>
+              <a:rPr lang="en-US" dirty="0" err="1"/>
+              <a:t>vaso</a:t>
+            </a:r>
+            <a:r>
+              <a:rPr lang="en-US" dirty="0"/>
+              <a:t> se </a:t>
+            </a:r>
+            <a:r>
+              <a:rPr lang="en-US" dirty="0" err="1"/>
+              <a:t>llena</a:t>
+            </a:r>
+            <a:r>
+              <a:rPr lang="en-US" dirty="0"/>
+              <a:t>, </a:t>
+            </a:r>
+            <a:r>
+              <a:rPr lang="en-US" dirty="0" err="1"/>
+              <a:t>cada</a:t>
+            </a:r>
+            <a:r>
+              <a:rPr lang="en-US" dirty="0"/>
+              <a:t> peso </a:t>
+            </a:r>
+            <a:r>
+              <a:rPr lang="en-US" dirty="0" err="1"/>
+              <a:t>adicional</a:t>
+            </a:r>
+            <a:r>
+              <a:rPr lang="en-US" dirty="0"/>
+              <a:t> </a:t>
+            </a:r>
+            <a:r>
+              <a:rPr lang="en-US" dirty="0" err="1"/>
+              <a:t>aporta</a:t>
+            </a:r>
+            <a:r>
+              <a:rPr lang="en-US" dirty="0"/>
+              <a:t> </a:t>
+            </a:r>
+            <a:r>
+              <a:rPr lang="en-US" dirty="0" err="1"/>
+              <a:t>menos</a:t>
+            </a:r>
+            <a:r>
+              <a:rPr lang="en-US" dirty="0"/>
+              <a:t>, hasta </a:t>
+            </a:r>
+            <a:r>
+              <a:rPr lang="en-US" dirty="0" err="1"/>
+              <a:t>que</a:t>
+            </a:r>
+            <a:r>
+              <a:rPr lang="en-US" dirty="0"/>
+              <a:t> </a:t>
+            </a:r>
+            <a:r>
+              <a:rPr lang="en-US" dirty="0" err="1"/>
+              <a:t>ya</a:t>
+            </a:r>
+            <a:r>
+              <a:rPr lang="en-US" dirty="0"/>
+              <a:t> no </a:t>
+            </a:r>
+            <a:r>
+              <a:rPr lang="en-US" dirty="0" err="1"/>
+              <a:t>entra</a:t>
+            </a:r>
+            <a:r>
+              <a:rPr lang="en-US" dirty="0"/>
+              <a:t> </a:t>
+            </a:r>
+            <a:r>
+              <a:rPr lang="en-US" dirty="0" err="1"/>
+              <a:t>más</a:t>
+            </a:r>
+            <a:r>
+              <a:rPr lang="en-US" dirty="0"/>
+              <a:t>.</a:t>
+            </a:r>
+            <a:br>
+              <a:rPr lang="en-US" dirty="0"/>
+            </a:br>
+            <a:br>
+              <a:rPr lang="en-US" dirty="0"/>
+            </a:br>
+            <a:r>
+              <a:rPr lang="en-US" dirty="0" err="1"/>
+              <a:t>Estas</a:t>
+            </a:r>
+            <a:r>
+              <a:rPr lang="en-US" dirty="0"/>
+              <a:t> </a:t>
+            </a:r>
+            <a:r>
+              <a:rPr lang="en-US" dirty="0" err="1"/>
+              <a:t>cifras</a:t>
+            </a:r>
+            <a:r>
+              <a:rPr lang="en-US" dirty="0"/>
+              <a:t> </a:t>
+            </a:r>
+            <a:r>
+              <a:rPr lang="en-US" dirty="0" err="1"/>
+              <a:t>salen</a:t>
+            </a:r>
+            <a:r>
+              <a:rPr lang="en-US" dirty="0"/>
+              <a:t> de </a:t>
+            </a:r>
+            <a:r>
+              <a:rPr lang="en-US" dirty="0" err="1"/>
+              <a:t>correr</a:t>
+            </a:r>
+            <a:r>
+              <a:rPr lang="en-US" dirty="0"/>
+              <a:t> la </a:t>
+            </a:r>
+            <a:r>
+              <a:rPr lang="en-US" dirty="0" err="1"/>
+              <a:t>inversión</a:t>
+            </a:r>
+            <a:r>
+              <a:rPr lang="en-US" dirty="0"/>
+              <a:t> real de </a:t>
+            </a:r>
+            <a:r>
+              <a:rPr lang="en-US" dirty="0" err="1"/>
+              <a:t>cada</a:t>
+            </a:r>
+            <a:r>
+              <a:rPr lang="en-US" dirty="0"/>
+              <a:t> canal a </a:t>
+            </a:r>
+            <a:r>
+              <a:rPr lang="en-US" dirty="0" err="1"/>
+              <a:t>través</a:t>
+            </a:r>
+            <a:r>
+              <a:rPr lang="en-US" dirty="0"/>
+              <a:t> de dos </a:t>
+            </a:r>
+            <a:r>
+              <a:rPr lang="en-US" dirty="0" err="1"/>
+              <a:t>fórmulas</a:t>
+            </a:r>
+            <a:r>
+              <a:rPr lang="en-US" dirty="0"/>
+              <a:t>, canal </a:t>
+            </a:r>
+            <a:r>
+              <a:rPr lang="en-US" dirty="0" err="1"/>
+              <a:t>por</a:t>
+            </a:r>
+            <a:r>
+              <a:rPr lang="en-US" dirty="0"/>
+              <a:t> canal.</a:t>
+            </a:r>
+          </a:p>
+          <a:p>
+            <a:pPr rtl="0"/>
+            <a:endParaRPr lang="en-US" dirty="0"/>
+          </a:p>
+          <a:p>
+            <a:pPr rtl="0"/>
+            <a:r>
+              <a:rPr lang="en-US" dirty="0"/>
+              <a:t>Primero </a:t>
+            </a:r>
+            <a:r>
+              <a:rPr lang="en-US" dirty="0" err="1"/>
+              <a:t>calibré</a:t>
+            </a:r>
+            <a:r>
+              <a:rPr lang="en-US" dirty="0"/>
+              <a:t> la memoria de </a:t>
+            </a:r>
+            <a:r>
+              <a:rPr lang="en-US" dirty="0" err="1"/>
+              <a:t>cada</a:t>
+            </a:r>
+            <a:r>
+              <a:rPr lang="en-US" dirty="0"/>
+              <a:t> canal. Para </a:t>
+            </a:r>
+            <a:r>
+              <a:rPr lang="en-US" dirty="0" err="1"/>
+              <a:t>cada</a:t>
+            </a:r>
+            <a:r>
+              <a:rPr lang="en-US" dirty="0"/>
+              <a:t> uno de </a:t>
+            </a:r>
+            <a:r>
+              <a:rPr lang="en-US" dirty="0" err="1"/>
+              <a:t>los</a:t>
+            </a:r>
+            <a:r>
+              <a:rPr lang="en-US" dirty="0"/>
+              <a:t> 8 </a:t>
+            </a:r>
+            <a:r>
+              <a:rPr lang="en-US" dirty="0" err="1"/>
+              <a:t>medios</a:t>
+            </a:r>
+            <a:r>
+              <a:rPr lang="en-US" dirty="0"/>
+              <a:t>, se </a:t>
+            </a:r>
+            <a:r>
+              <a:rPr lang="en-US" dirty="0" err="1"/>
+              <a:t>probó</a:t>
+            </a:r>
+            <a:r>
+              <a:rPr lang="en-US" dirty="0"/>
+              <a:t> 18 </a:t>
+            </a:r>
+            <a:r>
+              <a:rPr lang="en-US" dirty="0" err="1"/>
+              <a:t>combinaciones</a:t>
+            </a:r>
+            <a:r>
+              <a:rPr lang="en-US" dirty="0"/>
+              <a:t> </a:t>
+            </a:r>
+            <a:r>
+              <a:rPr lang="en-US" dirty="0" err="1"/>
+              <a:t>distintas</a:t>
+            </a:r>
+            <a:r>
+              <a:rPr lang="en-US" dirty="0"/>
+              <a:t> de '</a:t>
+            </a:r>
+            <a:r>
+              <a:rPr lang="en-US" dirty="0" err="1"/>
+              <a:t>cuánto</a:t>
+            </a:r>
+            <a:r>
+              <a:rPr lang="en-US" dirty="0"/>
+              <a:t> dura el </a:t>
+            </a:r>
+            <a:r>
+              <a:rPr lang="en-US" dirty="0" err="1"/>
+              <a:t>efecto</a:t>
+            </a:r>
+            <a:r>
+              <a:rPr lang="en-US" dirty="0"/>
+              <a:t> de </a:t>
+            </a:r>
+            <a:r>
+              <a:rPr lang="en-US" dirty="0" err="1"/>
+              <a:t>una</a:t>
+            </a:r>
+            <a:r>
+              <a:rPr lang="en-US" dirty="0"/>
+              <a:t> </a:t>
+            </a:r>
+            <a:r>
+              <a:rPr lang="en-US" dirty="0" err="1"/>
+              <a:t>campaña</a:t>
+            </a:r>
+            <a:r>
+              <a:rPr lang="en-US" dirty="0"/>
+              <a:t>' y me </a:t>
+            </a:r>
+            <a:r>
+              <a:rPr lang="en-US" dirty="0" err="1"/>
+              <a:t>quedé</a:t>
+            </a:r>
+            <a:r>
+              <a:rPr lang="en-US" dirty="0"/>
+              <a:t> con la </a:t>
+            </a:r>
+            <a:r>
+              <a:rPr lang="en-US" dirty="0" err="1"/>
+              <a:t>que</a:t>
+            </a:r>
+            <a:r>
+              <a:rPr lang="en-US" dirty="0"/>
+              <a:t> </a:t>
+            </a:r>
+            <a:r>
+              <a:rPr lang="en-US" dirty="0" err="1"/>
+              <a:t>mejor</a:t>
+            </a:r>
+            <a:r>
+              <a:rPr lang="en-US" dirty="0"/>
+              <a:t> </a:t>
+            </a:r>
+            <a:r>
+              <a:rPr lang="en-US" dirty="0" err="1"/>
+              <a:t>predijo</a:t>
+            </a:r>
+            <a:r>
+              <a:rPr lang="en-US" dirty="0"/>
+              <a:t> las </a:t>
+            </a:r>
+            <a:r>
+              <a:rPr lang="en-US" dirty="0" err="1"/>
+              <a:t>ventas</a:t>
+            </a:r>
+            <a:r>
+              <a:rPr lang="en-US" dirty="0"/>
+              <a:t> reales. </a:t>
+            </a:r>
+          </a:p>
+          <a:p>
+            <a:pPr rtl="0"/>
+            <a:endParaRPr lang="en-US" dirty="0"/>
+          </a:p>
+          <a:p>
+            <a:pPr rtl="0"/>
+            <a:r>
+              <a:rPr lang="en-US" dirty="0"/>
+              <a:t>Se </a:t>
+            </a:r>
+            <a:r>
+              <a:rPr lang="en-US" dirty="0" err="1"/>
+              <a:t>combinaron</a:t>
+            </a:r>
+            <a:r>
+              <a:rPr lang="en-US" dirty="0"/>
+              <a:t> </a:t>
+            </a:r>
+            <a:r>
+              <a:rPr lang="en-US" dirty="0" err="1"/>
+              <a:t>tres</a:t>
+            </a:r>
+            <a:r>
+              <a:rPr lang="en-US" dirty="0"/>
+              <a:t> </a:t>
+            </a:r>
+            <a:r>
+              <a:rPr lang="en-US" dirty="0" err="1"/>
+              <a:t>parámetros</a:t>
+            </a:r>
+            <a:r>
+              <a:rPr lang="en-US" dirty="0"/>
+              <a:t>, </a:t>
+            </a:r>
+            <a:r>
+              <a:rPr lang="en-US" dirty="0" err="1"/>
+              <a:t>cada</a:t>
+            </a:r>
+            <a:r>
+              <a:rPr lang="en-US" dirty="0"/>
+              <a:t> uno con sus </a:t>
+            </a:r>
+            <a:r>
+              <a:rPr lang="en-US" dirty="0" err="1"/>
+              <a:t>propias</a:t>
+            </a:r>
+            <a:r>
+              <a:rPr lang="en-US" dirty="0"/>
+              <a:t> </a:t>
+            </a:r>
+            <a:r>
+              <a:rPr lang="en-US" dirty="0" err="1"/>
+              <a:t>opciones</a:t>
+            </a:r>
+            <a:r>
+              <a:rPr lang="en-US" dirty="0"/>
+              <a:t>, y se </a:t>
+            </a:r>
+            <a:r>
+              <a:rPr lang="en-US" dirty="0" err="1"/>
+              <a:t>probaron</a:t>
+            </a:r>
+            <a:r>
+              <a:rPr lang="en-US" dirty="0"/>
+              <a:t> </a:t>
+            </a:r>
+            <a:r>
+              <a:rPr lang="en-US" dirty="0" err="1"/>
+              <a:t>todas</a:t>
+            </a:r>
+            <a:r>
+              <a:rPr lang="en-US" dirty="0"/>
+              <a:t> las </a:t>
+            </a:r>
+            <a:r>
+              <a:rPr lang="en-US" dirty="0" err="1"/>
+              <a:t>combinaciones</a:t>
+            </a:r>
+            <a:r>
+              <a:rPr lang="en-US" dirty="0"/>
+              <a:t> </a:t>
+            </a:r>
+            <a:r>
+              <a:rPr lang="en-US" dirty="0" err="1"/>
+              <a:t>posibles</a:t>
+            </a:r>
+            <a:r>
+              <a:rPr lang="en-US" dirty="0"/>
+              <a:t> entre </a:t>
+            </a:r>
+            <a:r>
+              <a:rPr lang="en-US" dirty="0" err="1"/>
+              <a:t>ellos</a:t>
+            </a:r>
+            <a:r>
+              <a:rPr lang="en-US" dirty="0"/>
+              <a:t>:</a:t>
+            </a:r>
+          </a:p>
+          <a:p>
+            <a:pPr lvl="0" rtl="0"/>
+            <a:r>
+              <a:rPr lang="en-US" b="1" dirty="0"/>
+              <a:t>θ (memoria):</a:t>
+            </a:r>
+            <a:r>
+              <a:rPr lang="en-US" dirty="0"/>
+              <a:t> 3 </a:t>
+            </a:r>
+            <a:r>
+              <a:rPr lang="en-US" dirty="0" err="1"/>
+              <a:t>opciones</a:t>
+            </a:r>
+            <a:r>
+              <a:rPr lang="en-US" dirty="0"/>
+              <a:t> — 0,3 / 0,5 / 0,7</a:t>
+            </a:r>
+          </a:p>
+          <a:p>
+            <a:pPr lvl="0" rtl="0"/>
+            <a:r>
+              <a:rPr lang="en-US" b="1" dirty="0"/>
+              <a:t>α (forma de la curva):</a:t>
+            </a:r>
+            <a:r>
+              <a:rPr lang="en-US" dirty="0"/>
+              <a:t> 2 </a:t>
+            </a:r>
+            <a:r>
+              <a:rPr lang="en-US" dirty="0" err="1"/>
+              <a:t>opciones</a:t>
+            </a:r>
+            <a:r>
+              <a:rPr lang="en-US" dirty="0"/>
+              <a:t> — 1 / 2</a:t>
+            </a:r>
+          </a:p>
+          <a:p>
+            <a:pPr lvl="0" rtl="0"/>
+            <a:r>
+              <a:rPr lang="en-US" b="1" dirty="0"/>
+              <a:t>γ (punto de </a:t>
+            </a:r>
+            <a:r>
+              <a:rPr lang="en-US" b="1" dirty="0" err="1"/>
+              <a:t>saturación</a:t>
+            </a:r>
+            <a:r>
+              <a:rPr lang="en-US" b="1" dirty="0"/>
+              <a:t>):</a:t>
+            </a:r>
+            <a:r>
+              <a:rPr lang="en-US" dirty="0"/>
+              <a:t> 3 </a:t>
+            </a:r>
+            <a:r>
+              <a:rPr lang="en-US" dirty="0" err="1"/>
+              <a:t>opciones</a:t>
+            </a:r>
+            <a:r>
+              <a:rPr lang="en-US" dirty="0"/>
+              <a:t> — </a:t>
+            </a:r>
+            <a:r>
+              <a:rPr lang="en-US" dirty="0" err="1"/>
+              <a:t>percentil</a:t>
+            </a:r>
+            <a:r>
+              <a:rPr lang="en-US" dirty="0"/>
+              <a:t> 25 / 50 / 75</a:t>
+            </a:r>
+          </a:p>
+          <a:p>
+            <a:pPr lvl="0" rtl="0"/>
+            <a:endParaRPr lang="en-US" dirty="0"/>
+          </a:p>
+          <a:p>
+            <a:pPr rtl="0"/>
+            <a:r>
+              <a:rPr lang="en-US" dirty="0"/>
+              <a:t>3 × 2 × 3 = </a:t>
+            </a:r>
+            <a:r>
+              <a:rPr lang="en-US" b="1" dirty="0"/>
+              <a:t>18 </a:t>
+            </a:r>
+            <a:r>
+              <a:rPr lang="en-US" b="1" dirty="0" err="1"/>
+              <a:t>combinaciones</a:t>
+            </a:r>
+            <a:r>
+              <a:rPr lang="en-US" dirty="0"/>
+              <a:t> para </a:t>
+            </a:r>
+            <a:r>
+              <a:rPr lang="en-US" dirty="0" err="1"/>
+              <a:t>cada</a:t>
+            </a:r>
+            <a:r>
+              <a:rPr lang="en-US" dirty="0"/>
+              <a:t> canal.</a:t>
+            </a:r>
+          </a:p>
+          <a:p>
+            <a:pPr rtl="0"/>
+            <a:r>
+              <a:rPr lang="en-US" dirty="0"/>
+              <a:t>Es </a:t>
+            </a:r>
+            <a:r>
+              <a:rPr lang="en-US" dirty="0" err="1"/>
+              <a:t>una</a:t>
+            </a:r>
+            <a:r>
+              <a:rPr lang="en-US" dirty="0"/>
+              <a:t> </a:t>
+            </a:r>
+            <a:r>
+              <a:rPr lang="en-US" dirty="0" err="1"/>
+              <a:t>grilla</a:t>
+            </a:r>
+            <a:r>
+              <a:rPr lang="en-US" dirty="0"/>
+              <a:t> </a:t>
+            </a:r>
+            <a:r>
+              <a:rPr lang="en-US" dirty="0" err="1"/>
+              <a:t>exhaustiva</a:t>
+            </a:r>
+            <a:r>
+              <a:rPr lang="en-US" dirty="0"/>
+              <a:t>: se </a:t>
+            </a:r>
+            <a:r>
+              <a:rPr lang="en-US" dirty="0" err="1"/>
+              <a:t>prueban</a:t>
+            </a:r>
+            <a:r>
+              <a:rPr lang="en-US" dirty="0"/>
+              <a:t> </a:t>
+            </a:r>
+            <a:r>
+              <a:rPr lang="en-US" dirty="0" err="1"/>
+              <a:t>todas</a:t>
+            </a:r>
+            <a:r>
+              <a:rPr lang="en-US" dirty="0"/>
+              <a:t> las </a:t>
+            </a:r>
+            <a:r>
+              <a:rPr lang="en-US" dirty="0" err="1"/>
+              <a:t>posibles</a:t>
+            </a:r>
+            <a:r>
+              <a:rPr lang="en-US" dirty="0"/>
+              <a:t> y se </a:t>
+            </a:r>
+            <a:r>
+              <a:rPr lang="en-US" dirty="0" err="1"/>
+              <a:t>elige</a:t>
+            </a:r>
+            <a:r>
+              <a:rPr lang="en-US" dirty="0"/>
+              <a:t> la </a:t>
+            </a:r>
+            <a:r>
+              <a:rPr lang="en-US" dirty="0" err="1"/>
+              <a:t>que</a:t>
+            </a:r>
+            <a:r>
+              <a:rPr lang="en-US" dirty="0"/>
+              <a:t> </a:t>
+            </a:r>
+            <a:r>
+              <a:rPr lang="en-US" dirty="0" err="1"/>
+              <a:t>mejor</a:t>
+            </a:r>
+            <a:r>
+              <a:rPr lang="en-US" dirty="0"/>
+              <a:t> </a:t>
+            </a:r>
+            <a:r>
+              <a:rPr lang="en-US" dirty="0" err="1"/>
+              <a:t>predijo</a:t>
+            </a:r>
+            <a:r>
+              <a:rPr lang="en-US" dirty="0"/>
+              <a:t> las </a:t>
+            </a:r>
+            <a:r>
+              <a:rPr lang="en-US" dirty="0" err="1"/>
+              <a:t>ventas</a:t>
+            </a:r>
+            <a:r>
+              <a:rPr lang="en-US" dirty="0"/>
+              <a:t> reales de ese canal </a:t>
+            </a:r>
+            <a:r>
+              <a:rPr lang="en-US" dirty="0" err="1"/>
+              <a:t>en</a:t>
+            </a:r>
+            <a:r>
+              <a:rPr lang="en-US" dirty="0"/>
+              <a:t> la </a:t>
+            </a:r>
+            <a:r>
+              <a:rPr lang="en-US" dirty="0" err="1"/>
+              <a:t>validación</a:t>
+            </a:r>
+            <a:r>
+              <a:rPr lang="en-US" dirty="0"/>
+              <a:t>.</a:t>
+            </a:r>
+          </a:p>
+          <a:p>
+            <a:pPr rtl="0"/>
+            <a:endParaRPr lang="en-US" dirty="0"/>
+          </a:p>
+          <a:p>
+            <a:pPr rtl="0"/>
+            <a:endParaRPr lang="en-US" dirty="0"/>
+          </a:p>
+          <a:p>
+            <a:pPr rtl="0"/>
+            <a:r>
+              <a:rPr lang="en-US" dirty="0"/>
+              <a:t>No es </a:t>
+            </a:r>
+            <a:r>
+              <a:rPr lang="en-US" dirty="0" err="1"/>
+              <a:t>una</a:t>
+            </a:r>
+            <a:r>
+              <a:rPr lang="en-US" dirty="0"/>
+              <a:t> </a:t>
+            </a:r>
+            <a:r>
+              <a:rPr lang="en-US" dirty="0" err="1"/>
+              <a:t>suposición</a:t>
+            </a:r>
+            <a:r>
+              <a:rPr lang="en-US" dirty="0"/>
+              <a:t>: es la </a:t>
+            </a:r>
+            <a:r>
+              <a:rPr lang="en-US" dirty="0" err="1"/>
+              <a:t>que</a:t>
+            </a:r>
+            <a:r>
+              <a:rPr lang="en-US" dirty="0"/>
+              <a:t> </a:t>
+            </a:r>
+            <a:r>
+              <a:rPr lang="en-US" dirty="0" err="1"/>
+              <a:t>ganó</a:t>
+            </a:r>
+            <a:r>
+              <a:rPr lang="en-US" dirty="0"/>
+              <a:t> contra las </a:t>
+            </a:r>
+            <a:r>
+              <a:rPr lang="en-US" dirty="0" err="1"/>
+              <a:t>otras</a:t>
+            </a:r>
+            <a:r>
+              <a:rPr lang="en-US" dirty="0"/>
+              <a:t> 17 </a:t>
+            </a:r>
+            <a:r>
+              <a:rPr lang="en-US" dirty="0" err="1"/>
+              <a:t>alternativas</a:t>
+            </a:r>
+            <a:r>
+              <a:rPr lang="en-US" dirty="0"/>
+              <a:t>. </a:t>
+            </a:r>
+            <a:r>
+              <a:rPr lang="en-US" dirty="0" err="1"/>
+              <a:t>Así</a:t>
+            </a:r>
+            <a:r>
+              <a:rPr lang="en-US" dirty="0"/>
+              <a:t> </a:t>
+            </a:r>
+            <a:r>
+              <a:rPr lang="en-US" dirty="0" err="1"/>
+              <a:t>encontré</a:t>
+            </a:r>
+            <a:r>
+              <a:rPr lang="en-US" dirty="0"/>
+              <a:t> </a:t>
+            </a:r>
+            <a:r>
+              <a:rPr lang="en-US" dirty="0" err="1"/>
+              <a:t>que</a:t>
+            </a:r>
+            <a:r>
+              <a:rPr lang="en-US" dirty="0"/>
+              <a:t> Facebook, YouTube, TV local y video digital </a:t>
+            </a:r>
+            <a:r>
+              <a:rPr lang="en-US" dirty="0" err="1"/>
+              <a:t>tienen</a:t>
+            </a:r>
+            <a:r>
+              <a:rPr lang="en-US" dirty="0"/>
+              <a:t> memoria </a:t>
+            </a:r>
+            <a:r>
+              <a:rPr lang="en-US" dirty="0" err="1"/>
+              <a:t>corta</a:t>
+            </a:r>
+            <a:r>
+              <a:rPr lang="en-US" dirty="0"/>
+              <a:t>, y </a:t>
+            </a:r>
+            <a:r>
+              <a:rPr lang="en-US" dirty="0" err="1"/>
+              <a:t>que</a:t>
+            </a:r>
+            <a:r>
+              <a:rPr lang="en-US" dirty="0"/>
+              <a:t> Instagram y radio </a:t>
+            </a:r>
+            <a:r>
+              <a:rPr lang="en-US" dirty="0" err="1"/>
+              <a:t>tienen</a:t>
+            </a:r>
+            <a:r>
+              <a:rPr lang="en-US" dirty="0"/>
+              <a:t> memoria </a:t>
+            </a:r>
+            <a:r>
+              <a:rPr lang="en-US" dirty="0" err="1"/>
+              <a:t>larga</a:t>
+            </a:r>
+            <a:r>
+              <a:rPr lang="en-US" dirty="0"/>
+              <a:t>. El </a:t>
+            </a:r>
+            <a:r>
+              <a:rPr lang="en-US" dirty="0" err="1"/>
+              <a:t>gráfico</a:t>
+            </a:r>
+            <a:r>
+              <a:rPr lang="en-US" dirty="0"/>
+              <a:t> de la </a:t>
+            </a:r>
+            <a:r>
+              <a:rPr lang="en-US" dirty="0" err="1"/>
+              <a:t>izquierda</a:t>
+            </a:r>
+            <a:r>
+              <a:rPr lang="en-US" dirty="0"/>
+              <a:t> solo </a:t>
+            </a:r>
+            <a:r>
+              <a:rPr lang="en-US" dirty="0" err="1"/>
+              <a:t>dibuja</a:t>
+            </a:r>
+            <a:r>
+              <a:rPr lang="en-US" dirty="0"/>
+              <a:t> </a:t>
+            </a:r>
+            <a:r>
+              <a:rPr lang="en-US" dirty="0" err="1"/>
+              <a:t>esa</a:t>
+            </a:r>
+            <a:r>
+              <a:rPr lang="en-US" dirty="0"/>
+              <a:t> </a:t>
+            </a:r>
+            <a:r>
+              <a:rPr lang="en-US" dirty="0" err="1"/>
+              <a:t>fórmula</a:t>
+            </a:r>
+            <a:r>
+              <a:rPr lang="en-US" dirty="0"/>
+              <a:t> </a:t>
+            </a:r>
+            <a:r>
+              <a:rPr lang="en-US" dirty="0" err="1"/>
+              <a:t>ya</a:t>
+            </a:r>
+            <a:r>
+              <a:rPr lang="en-US" dirty="0"/>
+              <a:t> </a:t>
+            </a:r>
+            <a:r>
+              <a:rPr lang="en-US" dirty="0" err="1"/>
+              <a:t>ganadora</a:t>
+            </a:r>
+            <a:r>
+              <a:rPr lang="en-US" dirty="0"/>
+              <a:t>, </a:t>
+            </a:r>
+            <a:r>
+              <a:rPr lang="en-US" dirty="0" err="1"/>
+              <a:t>semana</a:t>
+            </a:r>
+            <a:r>
+              <a:rPr lang="en-US" dirty="0"/>
+              <a:t> </a:t>
+            </a:r>
+            <a:r>
+              <a:rPr lang="en-US" dirty="0" err="1"/>
+              <a:t>por</a:t>
+            </a:r>
+            <a:r>
+              <a:rPr lang="en-US" dirty="0"/>
+              <a:t> </a:t>
+            </a:r>
+            <a:r>
+              <a:rPr lang="en-US" dirty="0" err="1"/>
+              <a:t>semana</a:t>
+            </a:r>
+            <a:r>
+              <a:rPr lang="en-US" dirty="0"/>
+              <a:t>.</a:t>
+            </a:r>
+          </a:p>
+          <a:p>
+            <a:pPr rtl="0"/>
+            <a:endParaRPr lang="en-US" dirty="0"/>
+          </a:p>
+          <a:p>
+            <a:pPr rtl="0"/>
+            <a:r>
+              <a:rPr lang="en-US" dirty="0"/>
+              <a:t>En </a:t>
+            </a:r>
+            <a:r>
+              <a:rPr lang="en-US" dirty="0" err="1"/>
+              <a:t>esa</a:t>
+            </a:r>
+            <a:r>
+              <a:rPr lang="en-US" dirty="0"/>
+              <a:t> </a:t>
+            </a:r>
+            <a:r>
+              <a:rPr lang="en-US" dirty="0" err="1"/>
+              <a:t>misma</a:t>
+            </a:r>
+            <a:r>
+              <a:rPr lang="en-US" dirty="0"/>
+              <a:t> </a:t>
+            </a:r>
+            <a:r>
+              <a:rPr lang="en-US" dirty="0" err="1"/>
+              <a:t>calibración</a:t>
+            </a:r>
+            <a:r>
+              <a:rPr lang="en-US" dirty="0"/>
+              <a:t> también </a:t>
+            </a:r>
+            <a:r>
+              <a:rPr lang="en-US" dirty="0" err="1"/>
+              <a:t>encontré</a:t>
+            </a:r>
+            <a:r>
+              <a:rPr lang="en-US" dirty="0"/>
+              <a:t> la curva de </a:t>
+            </a:r>
+            <a:r>
+              <a:rPr lang="en-US" dirty="0" err="1"/>
+              <a:t>saturación</a:t>
+            </a:r>
+            <a:r>
+              <a:rPr lang="en-US" dirty="0"/>
+              <a:t> de </a:t>
+            </a:r>
+            <a:r>
+              <a:rPr lang="en-US" dirty="0" err="1"/>
+              <a:t>cada</a:t>
+            </a:r>
+            <a:r>
+              <a:rPr lang="en-US" dirty="0"/>
+              <a:t> canal, o sea, </a:t>
+            </a:r>
+            <a:r>
+              <a:rPr lang="en-US" dirty="0" err="1"/>
+              <a:t>qué</a:t>
+            </a:r>
+            <a:r>
+              <a:rPr lang="en-US" dirty="0"/>
+              <a:t> tan </a:t>
+            </a:r>
+            <a:r>
+              <a:rPr lang="en-US" dirty="0" err="1"/>
+              <a:t>rápido</a:t>
+            </a:r>
+            <a:r>
+              <a:rPr lang="en-US" dirty="0"/>
+              <a:t> </a:t>
+            </a:r>
+            <a:r>
+              <a:rPr lang="en-US" dirty="0" err="1"/>
+              <a:t>deja</a:t>
+            </a:r>
+            <a:r>
+              <a:rPr lang="en-US" dirty="0"/>
+              <a:t> de </a:t>
+            </a:r>
+            <a:r>
+              <a:rPr lang="en-US" dirty="0" err="1"/>
+              <a:t>rendir</a:t>
+            </a:r>
+            <a:r>
+              <a:rPr lang="en-US" dirty="0"/>
+              <a:t> </a:t>
+            </a:r>
+            <a:r>
+              <a:rPr lang="en-US" dirty="0" err="1"/>
+              <a:t>cada</a:t>
+            </a:r>
+            <a:r>
+              <a:rPr lang="en-US" dirty="0"/>
+              <a:t> peso </a:t>
+            </a:r>
+            <a:r>
+              <a:rPr lang="en-US" dirty="0" err="1"/>
+              <a:t>adicional</a:t>
+            </a:r>
+            <a:r>
+              <a:rPr lang="en-US" dirty="0"/>
+              <a:t>. Esa es la curva </a:t>
+            </a:r>
+            <a:r>
+              <a:rPr lang="en-US" dirty="0" err="1"/>
+              <a:t>que</a:t>
+            </a:r>
+            <a:r>
+              <a:rPr lang="en-US" dirty="0"/>
+              <a:t> </a:t>
+            </a:r>
+            <a:r>
+              <a:rPr lang="en-US" dirty="0" err="1"/>
+              <a:t>ven</a:t>
+            </a:r>
+            <a:r>
+              <a:rPr lang="en-US" dirty="0"/>
+              <a:t> </a:t>
+            </a:r>
+            <a:r>
+              <a:rPr lang="en-US" dirty="0" err="1"/>
+              <a:t>dibujada</a:t>
+            </a:r>
+            <a:r>
+              <a:rPr lang="en-US" dirty="0"/>
+              <a:t> </a:t>
+            </a:r>
+            <a:r>
+              <a:rPr lang="en-US" dirty="0" err="1"/>
+              <a:t>en</a:t>
+            </a:r>
+            <a:r>
+              <a:rPr lang="en-US" dirty="0"/>
+              <a:t> </a:t>
+            </a:r>
+            <a:r>
+              <a:rPr lang="en-US" dirty="0" err="1"/>
+              <a:t>cada</a:t>
+            </a:r>
+            <a:r>
+              <a:rPr lang="en-US" dirty="0"/>
+              <a:t> panel de la </a:t>
+            </a:r>
+            <a:r>
+              <a:rPr lang="en-US" dirty="0" err="1"/>
+              <a:t>derecha</a:t>
+            </a:r>
+            <a:r>
+              <a:rPr lang="en-US" dirty="0"/>
+              <a:t>: es la </a:t>
+            </a:r>
+            <a:r>
+              <a:rPr lang="en-US" dirty="0" err="1"/>
+              <a:t>personalidad</a:t>
+            </a:r>
+            <a:r>
+              <a:rPr lang="en-US" dirty="0"/>
+              <a:t> de ese canal, </a:t>
+            </a:r>
+            <a:r>
+              <a:rPr lang="en-US" dirty="0" err="1"/>
+              <a:t>ya</a:t>
+            </a:r>
+            <a:r>
+              <a:rPr lang="en-US" dirty="0"/>
+              <a:t> </a:t>
+            </a:r>
+            <a:r>
+              <a:rPr lang="en-US" dirty="0" err="1"/>
+              <a:t>ajustada</a:t>
+            </a:r>
+            <a:r>
+              <a:rPr lang="en-US" dirty="0"/>
+              <a:t> con </a:t>
+            </a:r>
+            <a:r>
+              <a:rPr lang="en-US" dirty="0" err="1"/>
+              <a:t>nuestros</a:t>
+            </a:r>
+            <a:r>
+              <a:rPr lang="en-US" dirty="0"/>
+              <a:t> </a:t>
+            </a:r>
+            <a:r>
+              <a:rPr lang="en-US" dirty="0" err="1"/>
+              <a:t>datos</a:t>
+            </a:r>
+            <a:r>
+              <a:rPr lang="en-US" dirty="0"/>
+              <a:t>.</a:t>
+            </a:r>
+          </a:p>
+          <a:p>
+            <a:pPr rtl="0"/>
+            <a:endParaRPr lang="en-US" dirty="0"/>
+          </a:p>
+          <a:p>
+            <a:pPr rtl="0"/>
+            <a:r>
+              <a:rPr lang="en-US" dirty="0"/>
+              <a:t>Y </a:t>
+            </a:r>
+            <a:r>
+              <a:rPr lang="en-US" dirty="0" err="1"/>
+              <a:t>acá</a:t>
+            </a:r>
+            <a:r>
+              <a:rPr lang="en-US" dirty="0"/>
+              <a:t> </a:t>
+            </a:r>
+            <a:r>
+              <a:rPr lang="en-US" dirty="0" err="1"/>
+              <a:t>está</a:t>
+            </a:r>
+            <a:r>
+              <a:rPr lang="en-US" dirty="0"/>
+              <a:t> la </a:t>
+            </a:r>
+            <a:r>
+              <a:rPr lang="en-US" dirty="0" err="1"/>
+              <a:t>parte</a:t>
+            </a:r>
+            <a:r>
+              <a:rPr lang="en-US" dirty="0"/>
+              <a:t> </a:t>
+            </a:r>
+            <a:r>
+              <a:rPr lang="en-US" dirty="0" err="1"/>
+              <a:t>importante</a:t>
+            </a:r>
+            <a:r>
+              <a:rPr lang="en-US" dirty="0"/>
+              <a:t>. Una </a:t>
+            </a:r>
+            <a:r>
+              <a:rPr lang="en-US" dirty="0" err="1"/>
+              <a:t>vez</a:t>
+            </a:r>
+            <a:r>
+              <a:rPr lang="en-US" dirty="0"/>
+              <a:t> </a:t>
+            </a:r>
+            <a:r>
+              <a:rPr lang="en-US" dirty="0" err="1"/>
+              <a:t>que</a:t>
+            </a:r>
+            <a:r>
+              <a:rPr lang="en-US" dirty="0"/>
+              <a:t> </a:t>
+            </a:r>
+            <a:r>
+              <a:rPr lang="en-US" dirty="0" err="1"/>
+              <a:t>cada</a:t>
+            </a:r>
+            <a:r>
+              <a:rPr lang="en-US" dirty="0"/>
+              <a:t> canal </a:t>
+            </a:r>
+            <a:r>
+              <a:rPr lang="en-US" dirty="0" err="1"/>
+              <a:t>tiene</a:t>
+            </a:r>
+            <a:r>
+              <a:rPr lang="en-US" dirty="0"/>
+              <a:t> </a:t>
+            </a:r>
+            <a:r>
+              <a:rPr lang="en-US" dirty="0" err="1"/>
+              <a:t>su</a:t>
+            </a:r>
+            <a:r>
+              <a:rPr lang="en-US" dirty="0"/>
+              <a:t> </a:t>
+            </a:r>
+            <a:r>
+              <a:rPr lang="en-US" dirty="0" err="1"/>
+              <a:t>fórmula</a:t>
+            </a:r>
+            <a:r>
+              <a:rPr lang="en-US" dirty="0"/>
+              <a:t> de memoria y </a:t>
+            </a:r>
+            <a:r>
+              <a:rPr lang="en-US" dirty="0" err="1"/>
+              <a:t>su</a:t>
+            </a:r>
+            <a:r>
+              <a:rPr lang="en-US" dirty="0"/>
+              <a:t> curva </a:t>
+            </a:r>
+            <a:r>
+              <a:rPr lang="en-US" dirty="0" err="1"/>
+              <a:t>ya</a:t>
+            </a:r>
+            <a:r>
+              <a:rPr lang="en-US" dirty="0"/>
+              <a:t> </a:t>
+            </a:r>
+            <a:r>
+              <a:rPr lang="en-US" dirty="0" err="1"/>
+              <a:t>definidas</a:t>
+            </a:r>
+            <a:r>
+              <a:rPr lang="en-US" dirty="0"/>
+              <a:t>, </a:t>
+            </a:r>
+            <a:r>
+              <a:rPr lang="en-US" dirty="0" err="1"/>
+              <a:t>tomé</a:t>
+            </a:r>
+            <a:r>
+              <a:rPr lang="en-US" dirty="0"/>
+              <a:t> la </a:t>
+            </a:r>
+            <a:r>
+              <a:rPr lang="en-US" dirty="0" err="1"/>
+              <a:t>inversión</a:t>
+            </a:r>
+            <a:r>
+              <a:rPr lang="en-US" dirty="0"/>
+              <a:t> real </a:t>
+            </a:r>
+            <a:r>
+              <a:rPr lang="en-US" dirty="0" err="1"/>
+              <a:t>que</a:t>
+            </a:r>
+            <a:r>
+              <a:rPr lang="en-US" dirty="0"/>
+              <a:t> </a:t>
+            </a:r>
+            <a:r>
+              <a:rPr lang="en-US" dirty="0" err="1"/>
+              <a:t>hicimos</a:t>
+            </a:r>
+            <a:r>
+              <a:rPr lang="en-US" dirty="0"/>
+              <a:t> </a:t>
+            </a:r>
+            <a:r>
+              <a:rPr lang="en-US" dirty="0" err="1"/>
+              <a:t>en</a:t>
+            </a:r>
+            <a:r>
+              <a:rPr lang="en-US" dirty="0"/>
+              <a:t> las </a:t>
+            </a:r>
+            <a:r>
+              <a:rPr lang="en-US" dirty="0" err="1"/>
+              <a:t>últimas</a:t>
+            </a:r>
+            <a:r>
+              <a:rPr lang="en-US" dirty="0"/>
+              <a:t> </a:t>
+            </a:r>
+            <a:r>
+              <a:rPr lang="en-US" dirty="0" err="1"/>
+              <a:t>ocho</a:t>
+            </a:r>
+            <a:r>
+              <a:rPr lang="en-US" dirty="0"/>
+              <a:t> </a:t>
+            </a:r>
+            <a:r>
+              <a:rPr lang="en-US" dirty="0" err="1"/>
+              <a:t>semanas</a:t>
+            </a:r>
+            <a:r>
+              <a:rPr lang="en-US" dirty="0"/>
+              <a:t> y la </a:t>
+            </a:r>
+            <a:r>
+              <a:rPr lang="en-US" dirty="0" err="1"/>
+              <a:t>hice</a:t>
+            </a:r>
+            <a:r>
+              <a:rPr lang="en-US" dirty="0"/>
+              <a:t> pasar </a:t>
+            </a:r>
+            <a:r>
+              <a:rPr lang="en-US" dirty="0" err="1"/>
+              <a:t>por</a:t>
+            </a:r>
+            <a:r>
+              <a:rPr lang="en-US" dirty="0"/>
+              <a:t> </a:t>
+            </a:r>
+            <a:r>
+              <a:rPr lang="en-US" dirty="0" err="1"/>
+              <a:t>esa</a:t>
+            </a:r>
+            <a:r>
+              <a:rPr lang="en-US" dirty="0"/>
+              <a:t> </a:t>
+            </a:r>
+            <a:r>
+              <a:rPr lang="en-US" dirty="0" err="1"/>
+              <a:t>fórmula</a:t>
+            </a:r>
+            <a:r>
+              <a:rPr lang="en-US" dirty="0"/>
+              <a:t>. El </a:t>
+            </a:r>
+            <a:r>
+              <a:rPr lang="en-US" dirty="0" err="1"/>
+              <a:t>resultado</a:t>
+            </a:r>
+            <a:r>
+              <a:rPr lang="en-US" dirty="0"/>
+              <a:t> es un </a:t>
+            </a:r>
+            <a:r>
+              <a:rPr lang="en-US" dirty="0" err="1"/>
+              <a:t>número</a:t>
+            </a:r>
+            <a:r>
+              <a:rPr lang="en-US" dirty="0"/>
+              <a:t> entre 0 y 1 </a:t>
+            </a:r>
+            <a:r>
+              <a:rPr lang="en-US" dirty="0" err="1"/>
+              <a:t>que</a:t>
+            </a:r>
+            <a:r>
+              <a:rPr lang="en-US" dirty="0"/>
+              <a:t> me dice </a:t>
+            </a:r>
+            <a:r>
+              <a:rPr lang="en-US" dirty="0" err="1"/>
+              <a:t>qué</a:t>
+            </a:r>
+            <a:r>
+              <a:rPr lang="en-US" dirty="0"/>
+              <a:t> tan </a:t>
+            </a:r>
+            <a:r>
+              <a:rPr lang="en-US" dirty="0" err="1"/>
+              <a:t>cargado</a:t>
+            </a:r>
+            <a:r>
+              <a:rPr lang="en-US" dirty="0"/>
+              <a:t> </a:t>
+            </a:r>
+            <a:r>
+              <a:rPr lang="en-US" dirty="0" err="1"/>
+              <a:t>está</a:t>
+            </a:r>
+            <a:r>
+              <a:rPr lang="en-US" dirty="0"/>
+              <a:t> ese canal </a:t>
+            </a:r>
+            <a:r>
+              <a:rPr lang="en-US" dirty="0" err="1"/>
+              <a:t>ahora</a:t>
+            </a:r>
+            <a:r>
+              <a:rPr lang="en-US" dirty="0"/>
+              <a:t> </a:t>
+            </a:r>
+            <a:r>
+              <a:rPr lang="en-US" dirty="0" err="1"/>
+              <a:t>mismo</a:t>
+            </a:r>
+            <a:r>
+              <a:rPr lang="en-US" dirty="0"/>
+              <a:t>, con lo </a:t>
+            </a:r>
+            <a:r>
+              <a:rPr lang="en-US" dirty="0" err="1"/>
+              <a:t>que</a:t>
+            </a:r>
+            <a:r>
+              <a:rPr lang="en-US" dirty="0"/>
+              <a:t> de </a:t>
+            </a:r>
+            <a:r>
+              <a:rPr lang="en-US" dirty="0" err="1"/>
+              <a:t>verdad</a:t>
+            </a:r>
+            <a:r>
+              <a:rPr lang="en-US" dirty="0"/>
+              <a:t> </a:t>
+            </a:r>
+            <a:r>
+              <a:rPr lang="en-US" dirty="0" err="1"/>
+              <a:t>invertimos</a:t>
+            </a:r>
+            <a:r>
+              <a:rPr lang="en-US" dirty="0"/>
+              <a:t>.</a:t>
+            </a:r>
+          </a:p>
+          <a:p>
+            <a:pPr rtl="0"/>
+            <a:r>
+              <a:rPr lang="en-US" dirty="0"/>
+              <a:t>Ese </a:t>
+            </a:r>
+            <a:r>
+              <a:rPr lang="en-US" dirty="0" err="1"/>
+              <a:t>número</a:t>
+            </a:r>
+            <a:r>
+              <a:rPr lang="en-US" dirty="0"/>
+              <a:t> es el punto </a:t>
+            </a:r>
+            <a:r>
+              <a:rPr lang="en-US" dirty="0" err="1"/>
+              <a:t>en</a:t>
+            </a:r>
+            <a:r>
+              <a:rPr lang="en-US" dirty="0"/>
+              <a:t> la </a:t>
+            </a:r>
+            <a:r>
+              <a:rPr lang="en-US" dirty="0" err="1"/>
+              <a:t>gráfica</a:t>
+            </a:r>
+            <a:r>
+              <a:rPr lang="en-US" dirty="0"/>
+              <a:t>. Y ese </a:t>
+            </a:r>
+            <a:r>
+              <a:rPr lang="en-US" dirty="0" err="1"/>
+              <a:t>mismo</a:t>
+            </a:r>
+            <a:r>
+              <a:rPr lang="en-US" dirty="0"/>
+              <a:t> </a:t>
+            </a:r>
+            <a:r>
+              <a:rPr lang="en-US" dirty="0" err="1"/>
+              <a:t>número</a:t>
+            </a:r>
+            <a:r>
+              <a:rPr lang="en-US" dirty="0"/>
+              <a:t>, </a:t>
+            </a:r>
+            <a:r>
+              <a:rPr lang="en-US" dirty="0" err="1"/>
+              <a:t>en</a:t>
+            </a:r>
+            <a:r>
+              <a:rPr lang="en-US" dirty="0"/>
+              <a:t> </a:t>
+            </a:r>
+            <a:r>
+              <a:rPr lang="en-US" dirty="0" err="1"/>
+              <a:t>porcentaje</a:t>
+            </a:r>
+            <a:r>
+              <a:rPr lang="en-US" dirty="0"/>
+              <a:t>, es el 92 % o el 30 % del </a:t>
+            </a:r>
+            <a:r>
+              <a:rPr lang="en-US" dirty="0" err="1"/>
+              <a:t>título</a:t>
+            </a:r>
+            <a:r>
+              <a:rPr lang="en-US" dirty="0"/>
+              <a:t>.</a:t>
+            </a:r>
+          </a:p>
+          <a:p>
+            <a:pPr rtl="0"/>
+            <a:r>
+              <a:rPr lang="en-US" dirty="0" err="1"/>
+              <a:t>Entonces</a:t>
+            </a:r>
+            <a:r>
+              <a:rPr lang="en-US" dirty="0"/>
+              <a:t>, </a:t>
+            </a:r>
+            <a:r>
+              <a:rPr lang="en-US" dirty="0" err="1"/>
+              <a:t>cuando</a:t>
+            </a:r>
+            <a:r>
+              <a:rPr lang="en-US" dirty="0"/>
+              <a:t> </a:t>
+            </a:r>
+            <a:r>
+              <a:rPr lang="en-US" dirty="0" err="1"/>
+              <a:t>digo</a:t>
+            </a:r>
+            <a:r>
+              <a:rPr lang="en-US" dirty="0"/>
+              <a:t> </a:t>
+            </a:r>
+            <a:r>
+              <a:rPr lang="en-US" dirty="0" err="1"/>
+              <a:t>que</a:t>
+            </a:r>
+            <a:r>
+              <a:rPr lang="en-US" dirty="0"/>
+              <a:t> Facebook </a:t>
+            </a:r>
+            <a:r>
+              <a:rPr lang="en-US" dirty="0" err="1"/>
+              <a:t>está</a:t>
+            </a:r>
+            <a:r>
+              <a:rPr lang="en-US" dirty="0"/>
+              <a:t> al 92 %, lo </a:t>
+            </a:r>
+            <a:r>
+              <a:rPr lang="en-US" dirty="0" err="1"/>
+              <a:t>que</a:t>
+            </a:r>
+            <a:r>
+              <a:rPr lang="en-US" dirty="0"/>
+              <a:t> </a:t>
+            </a:r>
+            <a:r>
+              <a:rPr lang="en-US" dirty="0" err="1"/>
+              <a:t>estoy</a:t>
+            </a:r>
+            <a:r>
+              <a:rPr lang="en-US" dirty="0"/>
+              <a:t> </a:t>
+            </a:r>
+            <a:r>
+              <a:rPr lang="en-US" dirty="0" err="1"/>
+              <a:t>diciendo</a:t>
+            </a:r>
+            <a:r>
+              <a:rPr lang="en-US" dirty="0"/>
+              <a:t> es: con la </a:t>
+            </a:r>
+            <a:r>
+              <a:rPr lang="en-US" dirty="0" err="1"/>
+              <a:t>plata</a:t>
+            </a:r>
+            <a:r>
+              <a:rPr lang="en-US" dirty="0"/>
+              <a:t> </a:t>
+            </a:r>
+            <a:r>
+              <a:rPr lang="en-US" dirty="0" err="1"/>
+              <a:t>que</a:t>
+            </a:r>
+            <a:r>
+              <a:rPr lang="en-US" dirty="0"/>
+              <a:t> </a:t>
+            </a:r>
+            <a:r>
+              <a:rPr lang="en-US" dirty="0" err="1"/>
+              <a:t>invertimos</a:t>
+            </a:r>
+            <a:r>
+              <a:rPr lang="en-US" dirty="0"/>
+              <a:t> </a:t>
+            </a:r>
+            <a:r>
+              <a:rPr lang="en-US" dirty="0" err="1"/>
+              <a:t>en</a:t>
+            </a:r>
+            <a:r>
+              <a:rPr lang="en-US" dirty="0"/>
+              <a:t> Facebook </a:t>
+            </a:r>
+            <a:r>
+              <a:rPr lang="en-US" dirty="0" err="1"/>
+              <a:t>estas</a:t>
+            </a:r>
+            <a:r>
+              <a:rPr lang="en-US" dirty="0"/>
+              <a:t> </a:t>
+            </a:r>
+            <a:r>
+              <a:rPr lang="en-US" dirty="0" err="1"/>
+              <a:t>últimas</a:t>
+            </a:r>
+            <a:r>
+              <a:rPr lang="en-US" dirty="0"/>
+              <a:t> </a:t>
+            </a:r>
+            <a:r>
+              <a:rPr lang="en-US" dirty="0" err="1"/>
+              <a:t>semanas</a:t>
+            </a:r>
+            <a:r>
+              <a:rPr lang="en-US" dirty="0"/>
+              <a:t>, y con la </a:t>
+            </a:r>
+            <a:r>
+              <a:rPr lang="en-US" dirty="0" err="1"/>
+              <a:t>fórmula</a:t>
+            </a:r>
+            <a:r>
+              <a:rPr lang="en-US" dirty="0"/>
+              <a:t> </a:t>
+            </a:r>
+            <a:r>
+              <a:rPr lang="en-US" dirty="0" err="1"/>
+              <a:t>que</a:t>
+            </a:r>
+            <a:r>
+              <a:rPr lang="en-US" dirty="0"/>
+              <a:t> </a:t>
+            </a:r>
+            <a:r>
+              <a:rPr lang="en-US" dirty="0" err="1"/>
+              <a:t>mejor</a:t>
+            </a:r>
+            <a:r>
+              <a:rPr lang="en-US" dirty="0"/>
+              <a:t> </a:t>
+            </a:r>
+            <a:r>
+              <a:rPr lang="en-US" dirty="0" err="1"/>
+              <a:t>explica</a:t>
+            </a:r>
+            <a:r>
+              <a:rPr lang="en-US" dirty="0"/>
+              <a:t> </a:t>
+            </a:r>
+            <a:r>
+              <a:rPr lang="en-US" dirty="0" err="1"/>
+              <a:t>cómo</a:t>
+            </a:r>
+            <a:r>
+              <a:rPr lang="en-US" dirty="0"/>
+              <a:t> </a:t>
+            </a:r>
+            <a:r>
+              <a:rPr lang="en-US" dirty="0" err="1"/>
+              <a:t>responde</a:t>
+            </a:r>
+            <a:r>
+              <a:rPr lang="en-US" dirty="0"/>
+              <a:t> Facebook, el canal </a:t>
+            </a:r>
+            <a:r>
+              <a:rPr lang="en-US" dirty="0" err="1"/>
+              <a:t>está</a:t>
+            </a:r>
+            <a:r>
+              <a:rPr lang="en-US" dirty="0"/>
+              <a:t> </a:t>
+            </a:r>
+            <a:r>
+              <a:rPr lang="en-US" dirty="0" err="1"/>
+              <a:t>casi</a:t>
+            </a:r>
+            <a:r>
+              <a:rPr lang="en-US" dirty="0"/>
+              <a:t> </a:t>
+            </a:r>
+            <a:r>
+              <a:rPr lang="en-US" dirty="0" err="1"/>
+              <a:t>lleno</a:t>
+            </a:r>
+            <a:r>
+              <a:rPr lang="en-US" dirty="0"/>
+              <a:t>. Y </a:t>
+            </a:r>
+            <a:r>
+              <a:rPr lang="en-US" dirty="0" err="1"/>
+              <a:t>cuando</a:t>
+            </a:r>
+            <a:r>
+              <a:rPr lang="en-US" dirty="0"/>
+              <a:t> </a:t>
+            </a:r>
+            <a:r>
+              <a:rPr lang="en-US" dirty="0" err="1"/>
+              <a:t>digo</a:t>
+            </a:r>
+            <a:r>
+              <a:rPr lang="en-US" dirty="0"/>
+              <a:t> </a:t>
+            </a:r>
+            <a:r>
+              <a:rPr lang="en-US" dirty="0" err="1"/>
+              <a:t>que</a:t>
+            </a:r>
+            <a:r>
+              <a:rPr lang="en-US" dirty="0"/>
+              <a:t> TV local </a:t>
+            </a:r>
+            <a:r>
+              <a:rPr lang="en-US" dirty="0" err="1"/>
+              <a:t>está</a:t>
+            </a:r>
+            <a:r>
+              <a:rPr lang="en-US" dirty="0"/>
+              <a:t> al 30 %, es </a:t>
+            </a:r>
+            <a:r>
+              <a:rPr lang="en-US" dirty="0" err="1"/>
+              <a:t>que</a:t>
+            </a:r>
+            <a:r>
+              <a:rPr lang="en-US" dirty="0"/>
+              <a:t> con lo </a:t>
+            </a:r>
+            <a:r>
+              <a:rPr lang="en-US" dirty="0" err="1"/>
+              <a:t>que</a:t>
+            </a:r>
+            <a:r>
+              <a:rPr lang="en-US" dirty="0"/>
+              <a:t> </a:t>
+            </a:r>
+            <a:r>
+              <a:rPr lang="en-US" dirty="0" err="1"/>
+              <a:t>invertimos</a:t>
+            </a:r>
+            <a:r>
+              <a:rPr lang="en-US" dirty="0"/>
+              <a:t> ahí, </a:t>
+            </a:r>
+            <a:r>
+              <a:rPr lang="en-US" dirty="0" err="1"/>
+              <a:t>todavía</a:t>
+            </a:r>
+            <a:r>
+              <a:rPr lang="en-US" dirty="0"/>
+              <a:t> le </a:t>
+            </a:r>
+            <a:r>
+              <a:rPr lang="en-US" dirty="0" err="1"/>
+              <a:t>queda</a:t>
+            </a:r>
+            <a:r>
+              <a:rPr lang="en-US" dirty="0"/>
+              <a:t> </a:t>
+            </a:r>
+            <a:r>
+              <a:rPr lang="en-US" dirty="0" err="1"/>
+              <a:t>mucho</a:t>
+            </a:r>
+            <a:r>
+              <a:rPr lang="en-US" dirty="0"/>
+              <a:t> </a:t>
+            </a:r>
+            <a:r>
+              <a:rPr lang="en-US" dirty="0" err="1"/>
+              <a:t>espacio</a:t>
+            </a:r>
+            <a:r>
+              <a:rPr lang="en-US" dirty="0"/>
+              <a:t>.</a:t>
+            </a:r>
+          </a:p>
+          <a:p>
+            <a:pPr rtl="0"/>
+            <a:r>
+              <a:rPr lang="en-US" dirty="0"/>
+              <a:t>En </a:t>
+            </a:r>
+            <a:r>
+              <a:rPr lang="en-US" dirty="0" err="1"/>
+              <a:t>resumen</a:t>
+            </a:r>
+            <a:r>
+              <a:rPr lang="en-US" dirty="0"/>
+              <a:t>: </a:t>
+            </a:r>
+            <a:r>
+              <a:rPr lang="en-US" dirty="0" err="1"/>
+              <a:t>nuestra</a:t>
+            </a:r>
+            <a:r>
+              <a:rPr lang="en-US" dirty="0"/>
+              <a:t> </a:t>
+            </a:r>
+            <a:r>
+              <a:rPr lang="en-US" dirty="0" err="1"/>
+              <a:t>inversión</a:t>
+            </a:r>
+            <a:r>
+              <a:rPr lang="en-US" dirty="0"/>
+              <a:t> real </a:t>
+            </a:r>
+            <a:r>
+              <a:rPr lang="en-US" dirty="0" err="1"/>
+              <a:t>pasa</a:t>
+            </a:r>
+            <a:r>
+              <a:rPr lang="en-US" dirty="0"/>
+              <a:t> </a:t>
+            </a:r>
+            <a:r>
+              <a:rPr lang="en-US" dirty="0" err="1"/>
+              <a:t>por</a:t>
+            </a:r>
+            <a:r>
+              <a:rPr lang="en-US" dirty="0"/>
+              <a:t> la </a:t>
+            </a:r>
+            <a:r>
+              <a:rPr lang="en-US" dirty="0" err="1"/>
+              <a:t>fórmula</a:t>
+            </a:r>
+            <a:r>
+              <a:rPr lang="en-US" dirty="0"/>
+              <a:t> de memoria de ese canal, se </a:t>
+            </a:r>
+            <a:r>
+              <a:rPr lang="en-US" dirty="0" err="1"/>
+              <a:t>acumula</a:t>
+            </a:r>
+            <a:r>
+              <a:rPr lang="en-US" dirty="0"/>
+              <a:t>, y se </a:t>
+            </a:r>
+            <a:r>
+              <a:rPr lang="en-US" dirty="0" err="1"/>
+              <a:t>compara</a:t>
+            </a:r>
+            <a:r>
+              <a:rPr lang="en-US" dirty="0"/>
+              <a:t> contra </a:t>
+            </a:r>
+            <a:r>
+              <a:rPr lang="en-US" dirty="0" err="1"/>
+              <a:t>su</a:t>
+            </a:r>
+            <a:r>
+              <a:rPr lang="en-US" dirty="0"/>
+              <a:t> curva de </a:t>
+            </a:r>
+            <a:r>
+              <a:rPr lang="en-US" dirty="0" err="1"/>
+              <a:t>saturación</a:t>
+            </a:r>
+            <a:r>
+              <a:rPr lang="en-US" dirty="0"/>
+              <a:t>. Eso es lo </a:t>
+            </a:r>
+            <a:r>
+              <a:rPr lang="en-US" dirty="0" err="1"/>
+              <a:t>que</a:t>
+            </a:r>
+            <a:r>
+              <a:rPr lang="en-US" dirty="0"/>
+              <a:t> da el punto y el </a:t>
+            </a:r>
+            <a:r>
+              <a:rPr lang="en-US" dirty="0" err="1"/>
+              <a:t>porcentaje</a:t>
+            </a:r>
+            <a:r>
+              <a:rPr lang="en-US" dirty="0"/>
+              <a:t> </a:t>
+            </a:r>
+            <a:r>
+              <a:rPr lang="en-US" dirty="0" err="1"/>
+              <a:t>que</a:t>
+            </a:r>
+            <a:r>
+              <a:rPr lang="en-US" dirty="0"/>
+              <a:t> </a:t>
+            </a:r>
+            <a:r>
+              <a:rPr lang="en-US" dirty="0" err="1"/>
+              <a:t>ven</a:t>
+            </a:r>
+            <a:r>
+              <a:rPr lang="en-US" dirty="0"/>
+              <a:t> </a:t>
+            </a:r>
+            <a:r>
+              <a:rPr lang="en-US" dirty="0" err="1"/>
+              <a:t>acá</a:t>
+            </a:r>
+            <a:r>
+              <a:rPr lang="en-US" dirty="0"/>
+              <a:t>. No </a:t>
+            </a:r>
+            <a:r>
+              <a:rPr lang="en-US" dirty="0" err="1"/>
+              <a:t>elegí</a:t>
+            </a:r>
+            <a:r>
+              <a:rPr lang="en-US" dirty="0"/>
+              <a:t> </a:t>
+            </a:r>
+            <a:r>
+              <a:rPr lang="en-US" dirty="0" err="1"/>
+              <a:t>estos</a:t>
+            </a:r>
+            <a:r>
+              <a:rPr lang="en-US" dirty="0"/>
+              <a:t> </a:t>
+            </a:r>
+            <a:r>
+              <a:rPr lang="en-US" dirty="0" err="1"/>
+              <a:t>números</a:t>
+            </a:r>
+            <a:r>
+              <a:rPr lang="en-US" dirty="0"/>
+              <a:t> al </a:t>
+            </a:r>
+            <a:r>
+              <a:rPr lang="en-US" dirty="0" err="1"/>
+              <a:t>armar</a:t>
+            </a:r>
+            <a:r>
+              <a:rPr lang="en-US" dirty="0"/>
+              <a:t> la </a:t>
+            </a:r>
+            <a:r>
+              <a:rPr lang="en-US" dirty="0" err="1"/>
+              <a:t>lámina</a:t>
+            </a:r>
+            <a:r>
+              <a:rPr lang="en-US" dirty="0"/>
+              <a:t>: </a:t>
+            </a:r>
+            <a:r>
+              <a:rPr lang="en-US" dirty="0" err="1"/>
+              <a:t>salen</a:t>
+            </a:r>
+            <a:r>
+              <a:rPr lang="en-US" dirty="0"/>
+              <a:t> de </a:t>
+            </a:r>
+            <a:r>
+              <a:rPr lang="en-US" dirty="0" err="1"/>
+              <a:t>aplicar</a:t>
+            </a:r>
+            <a:r>
+              <a:rPr lang="en-US" dirty="0"/>
+              <a:t> </a:t>
+            </a:r>
+            <a:r>
+              <a:rPr lang="en-US" dirty="0" err="1"/>
+              <a:t>matemática</a:t>
+            </a:r>
+            <a:r>
+              <a:rPr lang="en-US" dirty="0"/>
+              <a:t> a </a:t>
+            </a:r>
+            <a:r>
+              <a:rPr lang="en-US" dirty="0" err="1"/>
+              <a:t>datos</a:t>
+            </a:r>
+            <a:r>
+              <a:rPr lang="en-US" dirty="0"/>
+              <a:t> reales, dos </a:t>
+            </a:r>
+            <a:r>
+              <a:rPr lang="en-US" dirty="0" err="1"/>
+              <a:t>veces</a:t>
+            </a:r>
+            <a:r>
+              <a:rPr lang="en-US" dirty="0"/>
+              <a:t>. Primero para encontrar la </a:t>
+            </a:r>
+            <a:r>
+              <a:rPr lang="en-US" dirty="0" err="1"/>
+              <a:t>fórmula</a:t>
+            </a:r>
+            <a:r>
+              <a:rPr lang="en-US" dirty="0"/>
+              <a:t> de </a:t>
+            </a:r>
+            <a:r>
+              <a:rPr lang="en-US" dirty="0" err="1"/>
+              <a:t>cada</a:t>
+            </a:r>
+            <a:r>
+              <a:rPr lang="en-US" dirty="0"/>
+              <a:t> canal, y </a:t>
+            </a:r>
+            <a:r>
+              <a:rPr lang="en-US" dirty="0" err="1"/>
+              <a:t>después</a:t>
+            </a:r>
+            <a:r>
+              <a:rPr lang="en-US" dirty="0"/>
+              <a:t> para </a:t>
+            </a:r>
+            <a:r>
+              <a:rPr lang="en-US" dirty="0" err="1"/>
+              <a:t>ubicar</a:t>
+            </a:r>
+            <a:r>
+              <a:rPr lang="en-US" dirty="0"/>
+              <a:t> </a:t>
+            </a:r>
+            <a:r>
+              <a:rPr lang="en-US" dirty="0" err="1"/>
+              <a:t>dónde</a:t>
+            </a:r>
+            <a:r>
+              <a:rPr lang="en-US" dirty="0"/>
+              <a:t> </a:t>
+            </a:r>
+            <a:r>
+              <a:rPr lang="en-US" dirty="0" err="1"/>
+              <a:t>está</a:t>
+            </a:r>
+            <a:r>
+              <a:rPr lang="en-US" dirty="0"/>
+              <a:t> </a:t>
+            </a:r>
+            <a:r>
+              <a:rPr lang="en-US" dirty="0" err="1"/>
+              <a:t>cada</a:t>
+            </a:r>
+            <a:r>
+              <a:rPr lang="en-US" dirty="0"/>
+              <a:t> uno hoy."</a:t>
+            </a:r>
+          </a:p>
+          <a:p>
+            <a:endParaRPr lang="en-US" dirty="0"/>
+          </a:p>
+          <a:p>
+            <a:endParaRPr lang="en-US" dirty="0"/>
+          </a:p>
+          <a:p>
+            <a:pPr rtl="0"/>
+            <a:endParaRPr lang="en-US" dirty="0"/>
+          </a:p>
+          <a:p>
+            <a:endParaRPr lang="en-US" dirty="0"/>
           </a:p>
         </p:txBody>
       </p:sp>
@@ -6498,7 +9710,18 @@
                 <a:ea typeface="Cambria" pitchFamily="34" charset="-122"/>
                 <a:cs typeface="Cambria" pitchFamily="34" charset="-120"/>
               </a:rPr>
-              <a:t>Adstock y saturación: qué significan θ, α y γ</a:t>
+              <a:t>Adstock y </a:t>
+            </a:r>
+            <a:r>
+              <a:rPr lang="en-US" sz="3000" b="1" dirty="0" err="1">
+                <a:solidFill>
+                  <a:srgbClr val="2B2520"/>
+                </a:solidFill>
+                <a:latin typeface="Cambria" pitchFamily="34" charset="0"/>
+                <a:ea typeface="Cambria" pitchFamily="34" charset="-122"/>
+                <a:cs typeface="Cambria" pitchFamily="34" charset="-120"/>
+              </a:rPr>
+              <a:t>saturación</a:t>
             </a:r>
             <a:endParaRPr lang="en-US" sz="3000" dirty="0"/>
           </a:p>
@@ -6923,7 +10146,18 @@
                 <a:ea typeface="Calibri" pitchFamily="34" charset="-122"/>
                 <a:cs typeface="Calibri" pitchFamily="34" charset="-120"/>
               </a:rPr>
-              <a:t>Theta: cuánto dura el recuerdo</a:t>
+              <a:t>Theta: cuánto dura el Recuerdo de la </a:t>
+            </a:r>
+            <a:r>
+              <a:rPr lang="en-US" sz="1300" b="1" dirty="0" err="1">
+                <a:solidFill>
+                  <a:srgbClr val="2B2520"/>
+                </a:solidFill>
+                <a:latin typeface="Calibri" pitchFamily="34" charset="0"/>
+                <a:ea typeface="Calibri" pitchFamily="34" charset="-122"/>
+                <a:cs typeface="Calibri" pitchFamily="34" charset="-120"/>
+              </a:rPr>
+              <a:t>publicidad</a:t>
             </a:r>
             <a:endParaRPr lang="en-US" sz="1300" dirty="0"/>
           </a:p>
@@ -7190,8 +10424,8 @@
         </p:nvSpPr>
         <p:spPr>
           <a:xfrm>
-            <a:off x="9850374" y="4389120"/>
-            <a:ext cx="1561338" cy="320040"/>
+            <a:off x="9728454" y="4288536"/>
+            <a:ext cx="1789938" cy="420624"/>
           </a:xfrm>
           <a:prstGeom prst="rect">
             <a:avLst/>
@@ -7215,7 +10449,73 @@
                 <a:ea typeface="Calibri" pitchFamily="34" charset="-122"/>
                 <a:cs typeface="Calibri" pitchFamily="34" charset="-120"/>
               </a:rPr>
-              <a:t>Gamma: la mitad</a:t>
+              <a:t>Gamma: </a:t>
+            </a:r>
+            <a:r>
+              <a:rPr lang="en-US" sz="1300" b="1" dirty="0" err="1">
+                <a:solidFill>
+                  <a:srgbClr val="2B2520"/>
+                </a:solidFill>
+                <a:latin typeface="Calibri" pitchFamily="34" charset="0"/>
+                <a:ea typeface="Calibri" pitchFamily="34" charset="-122"/>
+                <a:cs typeface="Calibri" pitchFamily="34" charset="-120"/>
+              </a:rPr>
+              <a:t>llegando</a:t>
+            </a:r>
+            <a:r>
+              <a:rPr lang="en-US" sz="1300" b="1" dirty="0">
+                <a:solidFill>
+                  <a:srgbClr val="2B2520"/>
+                </a:solidFill>
+                <a:latin typeface="Calibri" pitchFamily="34" charset="0"/>
+                <a:ea typeface="Calibri" pitchFamily="34" charset="-122"/>
+                <a:cs typeface="Calibri" pitchFamily="34" charset="-120"/>
+              </a:rPr>
+              <a:t> a </a:t>
+            </a:r>
+            <a:r>
+              <a:rPr lang="en-US" sz="1300" b="1" dirty="0" err="1">
+                <a:solidFill>
+                  <a:srgbClr val="2B2520"/>
+                </a:solidFill>
+                <a:latin typeface="Calibri" pitchFamily="34" charset="0"/>
+                <a:ea typeface="Calibri" pitchFamily="34" charset="-122"/>
+                <a:cs typeface="Calibri" pitchFamily="34" charset="-120"/>
+              </a:rPr>
+              <a:t>mitad</a:t>
+            </a:r>
+            <a:r>
+              <a:rPr lang="en-US" sz="1300" b="1" dirty="0">
+                <a:solidFill>
+                  <a:srgbClr val="2B2520"/>
+                </a:solidFill>
+                <a:latin typeface="Calibri" pitchFamily="34" charset="0"/>
+                <a:ea typeface="Calibri" pitchFamily="34" charset="-122"/>
+                <a:cs typeface="Calibri" pitchFamily="34" charset="-120"/>
+              </a:rPr>
+              <a:t> del m</a:t>
+            </a:r>
+            <a:r>
+              <a:rPr lang="es-SV" sz="1300" b="1" dirty="0" err="1">
+                <a:solidFill>
+                  <a:srgbClr val="2B2520"/>
+                </a:solidFill>
+                <a:latin typeface="Calibri" pitchFamily="34" charset="0"/>
+                <a:ea typeface="Calibri" pitchFamily="34" charset="-122"/>
+                <a:cs typeface="Calibri" pitchFamily="34" charset="-120"/>
+              </a:rPr>
+              <a:t>áximo</a:t>
+            </a:r>
+            <a:r>
+              <a:rPr lang="es-SV" sz="1300" b="1" dirty="0">
+                <a:solidFill>
+                  <a:srgbClr val="2B2520"/>
+                </a:solidFill>
+                <a:latin typeface="Calibri" pitchFamily="34" charset="0"/>
+                <a:ea typeface="Calibri" pitchFamily="34" charset="-122"/>
+                <a:cs typeface="Calibri" pitchFamily="34" charset="-120"/>
+              </a:rPr>
+              <a:t> efecto</a:t>
             </a:r>
             <a:endParaRPr lang="en-US" sz="1300" dirty="0"/>
           </a:p>
@@ -7534,7 +10834,111 @@
                 <a:ea typeface="Calibri" pitchFamily="34" charset="-122"/>
                 <a:cs typeface="Calibri" pitchFamily="34" charset="-120"/>
               </a:rPr>
-              <a:t>Cada canal se evaluó con 18 combinaciones de θ, α y γ. Se seleccionó la de menor RMSE en la ventana de validación, condicionada a un coeficiente positivo.</a:t>
+              <a:t>Cada canal se evaluó con 18 combinaciones de θ, α y γ. </a:t>
+            </a:r>
+          </a:p>
+          <a:p>
+            <a:pPr marL="0" indent="0">
+              <a:buNone/>
+            </a:pPr>
+            <a:r>
+              <a:rPr lang="en-US" sz="1250" dirty="0">
+                <a:solidFill>
+                  <a:srgbClr val="2B2520"/>
+                </a:solidFill>
+                <a:latin typeface="Calibri" pitchFamily="34" charset="0"/>
+                <a:ea typeface="Calibri" pitchFamily="34" charset="-122"/>
+                <a:cs typeface="Calibri" pitchFamily="34" charset="-120"/>
+              </a:rPr>
+              <a:t>Se </a:t>
+            </a:r>
+            <a:r>
+              <a:rPr lang="en-US" sz="1250" dirty="0" err="1">
+                <a:solidFill>
+                  <a:srgbClr val="2B2520"/>
+                </a:solidFill>
+                <a:latin typeface="Calibri" pitchFamily="34" charset="0"/>
+                <a:ea typeface="Calibri" pitchFamily="34" charset="-122"/>
+                <a:cs typeface="Calibri" pitchFamily="34" charset="-120"/>
+              </a:rPr>
+              <a:t>seleccionó</a:t>
+            </a:r>
+            <a:r>
+              <a:rPr lang="en-US" sz="1250" dirty="0">
+                <a:solidFill>
+                  <a:srgbClr val="2B2520"/>
+                </a:solidFill>
+                <a:latin typeface="Calibri" pitchFamily="34" charset="0"/>
+                <a:ea typeface="Calibri" pitchFamily="34" charset="-122"/>
+                <a:cs typeface="Calibri" pitchFamily="34" charset="-120"/>
+              </a:rPr>
+              <a:t> el major con base </a:t>
+            </a:r>
+            <a:r>
+              <a:rPr lang="en-US" sz="1250" dirty="0" err="1">
+                <a:solidFill>
+                  <a:srgbClr val="2B2520"/>
+                </a:solidFill>
+                <a:latin typeface="Calibri" pitchFamily="34" charset="0"/>
+                <a:ea typeface="Calibri" pitchFamily="34" charset="-122"/>
+                <a:cs typeface="Calibri" pitchFamily="34" charset="-120"/>
+              </a:rPr>
+              <a:t>en</a:t>
+            </a:r>
+            <a:r>
+              <a:rPr lang="en-US" sz="1250" dirty="0">
+                <a:solidFill>
+                  <a:srgbClr val="2B2520"/>
+                </a:solidFill>
+                <a:latin typeface="Calibri" pitchFamily="34" charset="0"/>
+                <a:ea typeface="Calibri" pitchFamily="34" charset="-122"/>
+                <a:cs typeface="Calibri" pitchFamily="34" charset="-120"/>
+              </a:rPr>
+              <a:t> el </a:t>
+            </a:r>
+            <a:r>
+              <a:rPr lang="en-US" sz="1250" dirty="0" err="1">
+                <a:solidFill>
+                  <a:srgbClr val="2B2520"/>
+                </a:solidFill>
+                <a:latin typeface="Calibri" pitchFamily="34" charset="0"/>
+                <a:ea typeface="Calibri" pitchFamily="34" charset="-122"/>
+                <a:cs typeface="Calibri" pitchFamily="34" charset="-120"/>
+              </a:rPr>
+              <a:t>menor</a:t>
+            </a:r>
+            <a:r>
+              <a:rPr lang="en-US" sz="1250" dirty="0">
+                <a:solidFill>
+                  <a:srgbClr val="2B2520"/>
+                </a:solidFill>
+                <a:latin typeface="Calibri" pitchFamily="34" charset="0"/>
+                <a:ea typeface="Calibri" pitchFamily="34" charset="-122"/>
+                <a:cs typeface="Calibri" pitchFamily="34" charset="-120"/>
+              </a:rPr>
+              <a:t> RMSE en la ventana de </a:t>
+            </a:r>
+            <a:r>
+              <a:rPr lang="en-US" sz="1250" dirty="0" err="1">
+                <a:solidFill>
+                  <a:srgbClr val="2B2520"/>
+                </a:solidFill>
+                <a:latin typeface="Calibri" pitchFamily="34" charset="0"/>
+                <a:ea typeface="Calibri" pitchFamily="34" charset="-122"/>
+                <a:cs typeface="Calibri" pitchFamily="34" charset="-120"/>
+              </a:rPr>
+              <a:t>validación</a:t>
+            </a:r>
+            <a:r>
+              <a:rPr lang="en-US" sz="1250" dirty="0">
+                <a:solidFill>
+                  <a:srgbClr val="2B2520"/>
+                </a:solidFill>
+                <a:latin typeface="Calibri" pitchFamily="34" charset="0"/>
+                <a:ea typeface="Calibri" pitchFamily="34" charset="-122"/>
+                <a:cs typeface="Calibri" pitchFamily="34" charset="-120"/>
+              </a:rPr>
+              <a:t>.</a:t>
             </a:r>
             <a:endParaRPr lang="en-US" sz="1250" dirty="0"/>
           </a:p>
@@ -10408,7 +13812,40 @@
                 <a:ea typeface="Cambria" pitchFamily="34" charset="-122"/>
                 <a:cs typeface="Cambria" pitchFamily="34" charset="-120"/>
               </a:rPr>
-              <a:t>Adstock y saturación por canal</a:t>
+              <a:t>Adstock y saturación </a:t>
+            </a:r>
+            <a:r>
+              <a:rPr lang="en-US" sz="3000" b="1" dirty="0" err="1">
+                <a:solidFill>
+                  <a:srgbClr val="2B2520"/>
+                </a:solidFill>
+                <a:latin typeface="Cambria" pitchFamily="34" charset="0"/>
+                <a:ea typeface="Cambria" pitchFamily="34" charset="-122"/>
+                <a:cs typeface="Cambria" pitchFamily="34" charset="-120"/>
+              </a:rPr>
+              <a:t>por</a:t>
+            </a:r>
+            <a:r>
+              <a:rPr lang="en-US" sz="3000" b="1" dirty="0">
+                <a:solidFill>
+                  <a:srgbClr val="2B2520"/>
+                </a:solidFill>
+                <a:latin typeface="Cambria" pitchFamily="34" charset="0"/>
+                <a:ea typeface="Cambria" pitchFamily="34" charset="-122"/>
+                <a:cs typeface="Cambria" pitchFamily="34" charset="-120"/>
+              </a:rPr>
+              <a:t> canal </a:t>
+            </a:r>
+            <a:r>
+              <a:rPr lang="en-US" sz="3000" b="1" dirty="0" err="1">
+                <a:solidFill>
+                  <a:srgbClr val="2B2520"/>
+                </a:solidFill>
+                <a:latin typeface="Cambria" pitchFamily="34" charset="0"/>
+                <a:ea typeface="Cambria" pitchFamily="34" charset="-122"/>
+                <a:cs typeface="Cambria" pitchFamily="34" charset="-120"/>
+              </a:rPr>
+              <a:t>publicitario</a:t>
             </a:r>
             <a:endParaRPr lang="en-US" sz="3000" dirty="0"/>
           </a:p>
@@ -10725,7 +14162,51 @@
                 <a:ea typeface="Calibri" pitchFamily="34" charset="-122"/>
                 <a:cs typeface="Calibri" pitchFamily="34" charset="-120"/>
               </a:rPr>
-              <a:t>: señal positiva; </a:t>
+              <a:t>: </a:t>
+            </a:r>
+            <a:r>
+              <a:rPr lang="en-US" sz="950" dirty="0" err="1">
+                <a:solidFill>
+                  <a:srgbClr val="6E655B"/>
+                </a:solidFill>
+                <a:latin typeface="Calibri" pitchFamily="34" charset="0"/>
+                <a:ea typeface="Calibri" pitchFamily="34" charset="-122"/>
+                <a:cs typeface="Calibri" pitchFamily="34" charset="-120"/>
+              </a:rPr>
+              <a:t>señal</a:t>
+            </a:r>
+            <a:r>
+              <a:rPr lang="en-US" sz="950" dirty="0">
+                <a:solidFill>
+                  <a:srgbClr val="6E655B"/>
+                </a:solidFill>
+                <a:latin typeface="Calibri" pitchFamily="34" charset="0"/>
+                <a:ea typeface="Calibri" pitchFamily="34" charset="-122"/>
+                <a:cs typeface="Calibri" pitchFamily="34" charset="-120"/>
+              </a:rPr>
+              <a:t> positive </a:t>
+            </a:r>
+            <a:r>
+              <a:rPr lang="en-US" sz="950" dirty="0" err="1">
+                <a:solidFill>
+                  <a:srgbClr val="6E655B"/>
+                </a:solidFill>
+                <a:latin typeface="Calibri" pitchFamily="34" charset="0"/>
+                <a:ea typeface="Calibri" pitchFamily="34" charset="-122"/>
+                <a:cs typeface="Calibri" pitchFamily="34" charset="-120"/>
+              </a:rPr>
+              <a:t>significativa</a:t>
+            </a:r>
+            <a:r>
+              <a:rPr lang="en-US" sz="950" dirty="0">
+                <a:solidFill>
+                  <a:srgbClr val="6E655B"/>
+                </a:solidFill>
+                <a:latin typeface="Calibri" pitchFamily="34" charset="0"/>
+                <a:ea typeface="Calibri" pitchFamily="34" charset="-122"/>
+                <a:cs typeface="Calibri" pitchFamily="34" charset="-120"/>
+              </a:rPr>
+              <a:t>; </a:t>
             </a:r>
             <a:r>
               <a:rPr lang="en-US" sz="950" b="1" dirty="0">
@@ -10747,7 +14228,29 @@
                 <a:ea typeface="Calibri" pitchFamily="34" charset="-122"/>
                 <a:cs typeface="Calibri" pitchFamily="34" charset="-120"/>
               </a:rPr>
-              <a:t>: negativa; gris: no significativa.</a:t>
+              <a:t>: negative </a:t>
+            </a:r>
+            <a:r>
+              <a:rPr lang="en-US" sz="950" dirty="0" err="1">
+                <a:solidFill>
+                  <a:srgbClr val="6E655B"/>
+                </a:solidFill>
+                <a:latin typeface="Calibri" pitchFamily="34" charset="0"/>
+                <a:ea typeface="Calibri" pitchFamily="34" charset="-122"/>
+                <a:cs typeface="Calibri" pitchFamily="34" charset="-120"/>
+              </a:rPr>
+              <a:t>significativa</a:t>
+            </a:r>
+            <a:r>
+              <a:rPr lang="en-US" sz="950" dirty="0">
+                <a:solidFill>
+                  <a:srgbClr val="6E655B"/>
+                </a:solidFill>
+                <a:latin typeface="Calibri" pitchFamily="34" charset="0"/>
+                <a:ea typeface="Calibri" pitchFamily="34" charset="-122"/>
+                <a:cs typeface="Calibri" pitchFamily="34" charset="-120"/>
+              </a:rPr>
+              <a:t>; gris: no significativa.</a:t>
             </a:r>
             <a:endParaRPr lang="en-US" sz="950" dirty="0"/>
           </a:p>
@@ -10829,6 +14332,177 @@
               <a:t>en Facebook, YouTube y TV local la mitad del efecto se disipa en menos de una semana. TV local combina señal positiva y margen en su curva (30 %), por lo que es el mejor candidato para probar más inversión; Facebook ya opera cerca del techo (92 %).</a:t>
             </a:r>
             <a:endParaRPr lang="en-US" sz="1100" dirty="0"/>
+          </a:p>
+        </p:txBody>
+      </p:sp>
+      <p:sp>
+        <p:nvSpPr>
+          <p:cNvPr id="14" name="TextBox 13">
+            <a:extLst>
+              <a:ext uri="{FF2B5EF4-FFF2-40B4-BE49-F238E27FC236}">
+                <a16:creationId xmlns:a16="http://schemas.microsoft.com/office/drawing/2014/main" id="{F8912FD1-178C-65ED-C604-7604D2B51945}"/>
+              </a:ext>
+            </a:extLst>
+          </p:cNvPr>
+          <p:cNvSpPr txBox="1"/>
+          <p:nvPr/>
+        </p:nvSpPr>
+        <p:spPr>
+          <a:xfrm>
+            <a:off x="8632952" y="686907"/>
+            <a:ext cx="3172968" cy="830997"/>
+          </a:xfrm>
+          <a:prstGeom prst="rect">
+            <a:avLst/>
+          </a:prstGeom>
+          <a:noFill/>
+        </p:spPr>
+        <p:txBody>
+          <a:bodyPr wrap="square">
+            <a:spAutoFit/>
+          </a:bodyPr>
+          <a:lstStyle/>
+          <a:p>
+            <a:r>
+              <a:rPr lang="en-US" sz="1200" dirty="0"/>
+              <a:t>Facebook </a:t>
+            </a:r>
+            <a:r>
+              <a:rPr lang="en-US" sz="1200" dirty="0" err="1"/>
+              <a:t>ya</a:t>
+            </a:r>
+            <a:r>
+              <a:rPr lang="en-US" sz="1200" dirty="0"/>
+              <a:t> </a:t>
+            </a:r>
+            <a:r>
+              <a:rPr lang="en-US" sz="1200" dirty="0" err="1"/>
+              <a:t>está</a:t>
+            </a:r>
+            <a:r>
+              <a:rPr lang="en-US" sz="1200" dirty="0"/>
+              <a:t> </a:t>
+            </a:r>
+            <a:r>
+              <a:rPr lang="en-US" sz="1200" dirty="0" err="1"/>
+              <a:t>casi</a:t>
+            </a:r>
+            <a:r>
+              <a:rPr lang="en-US" sz="1200" dirty="0"/>
+              <a:t> </a:t>
+            </a:r>
+            <a:r>
+              <a:rPr lang="en-US" sz="1200" dirty="0" err="1"/>
+              <a:t>lleno</a:t>
+            </a:r>
+            <a:r>
+              <a:rPr lang="en-US" sz="1200" dirty="0"/>
+              <a:t> (92%): </a:t>
+            </a:r>
+            <a:r>
+              <a:rPr lang="en-US" sz="1200" dirty="0" err="1"/>
+              <a:t>más</a:t>
+            </a:r>
+            <a:r>
+              <a:rPr lang="en-US" sz="1200" dirty="0"/>
+              <a:t> </a:t>
+            </a:r>
+            <a:r>
+              <a:rPr lang="en-US" sz="1200" dirty="0" err="1"/>
+              <a:t>inversión</a:t>
+            </a:r>
+            <a:r>
+              <a:rPr lang="en-US" sz="1200" dirty="0"/>
+              <a:t> ahí </a:t>
+            </a:r>
+            <a:r>
+              <a:rPr lang="en-US" sz="1200" dirty="0" err="1"/>
+              <a:t>rinde</a:t>
+            </a:r>
+            <a:r>
+              <a:rPr lang="en-US" sz="1200" dirty="0"/>
+              <a:t> poco. TV local, </a:t>
+            </a:r>
+            <a:r>
+              <a:rPr lang="en-US" sz="1200" dirty="0" err="1"/>
+              <a:t>en</a:t>
+            </a:r>
+            <a:r>
+              <a:rPr lang="en-US" sz="1200" dirty="0"/>
+              <a:t> </a:t>
+            </a:r>
+            <a:r>
+              <a:rPr lang="en-US" sz="1200" dirty="0" err="1"/>
+              <a:t>cambio</a:t>
+            </a:r>
+            <a:r>
+              <a:rPr lang="en-US" sz="1200" dirty="0"/>
+              <a:t>, </a:t>
+            </a:r>
+            <a:r>
+              <a:rPr lang="en-US" sz="1200" dirty="0" err="1"/>
+              <a:t>está</a:t>
+            </a:r>
+            <a:r>
+              <a:rPr lang="en-US" sz="1200" dirty="0"/>
+              <a:t> al 30 % y con </a:t>
+            </a:r>
+            <a:r>
+              <a:rPr lang="en-US" sz="1200" dirty="0" err="1"/>
+              <a:t>evidencia</a:t>
+            </a:r>
+            <a:r>
+              <a:rPr lang="en-US" sz="1200" dirty="0"/>
+              <a:t> de </a:t>
+            </a:r>
+            <a:r>
+              <a:rPr lang="en-US" sz="1200" dirty="0" err="1"/>
+              <a:t>que</a:t>
+            </a:r>
+            <a:r>
+              <a:rPr lang="en-US" sz="1200" dirty="0"/>
+              <a:t> </a:t>
+            </a:r>
+            <a:r>
+              <a:rPr lang="en-US" sz="1200" dirty="0" err="1"/>
+              <a:t>funciona</a:t>
+            </a:r>
+            <a:r>
+              <a:rPr lang="en-US" sz="1200" dirty="0"/>
+              <a:t>. Por </a:t>
+            </a:r>
+            <a:r>
+              <a:rPr lang="en-US" sz="1200" dirty="0" err="1"/>
+              <a:t>eso</a:t>
+            </a:r>
+            <a:r>
+              <a:rPr lang="en-US" sz="1200" dirty="0"/>
+              <a:t> es el primer </a:t>
+            </a:r>
+            <a:r>
+              <a:rPr lang="en-US" sz="1200" dirty="0" err="1"/>
+              <a:t>candidato</a:t>
+            </a:r>
+            <a:r>
+              <a:rPr lang="en-US" sz="1200" dirty="0"/>
+              <a:t> para </a:t>
+            </a:r>
+            <a:r>
+              <a:rPr lang="en-US" sz="1200" dirty="0" err="1"/>
+              <a:t>probar</a:t>
+            </a:r>
+            <a:r>
+              <a:rPr lang="en-US" sz="1200" dirty="0"/>
+              <a:t> </a:t>
+            </a:r>
+            <a:r>
+              <a:rPr lang="en-US" sz="1200" dirty="0" err="1"/>
+              <a:t>más</a:t>
+            </a:r>
+            <a:r>
+              <a:rPr lang="en-US" sz="1200" dirty="0"/>
+              <a:t> inversion.</a:t>
+            </a:r>
           </a:p>
         </p:txBody>
       </p:sp>
@@ -10921,7 +14595,7 @@
               <a:buNone/>
             </a:pPr>
             <a:r>
-              <a:rPr lang="en-US" sz="3000" b="1" dirty="0">
+              <a:rPr lang="en-US" sz="3000" b="1" dirty="0" err="1">
                 <a:solidFill>
                   <a:srgbClr val="2B2520"/>
                 </a:solidFill>
@@ -10929,7 +14603,29 @@
                 <a:ea typeface="Cambria" pitchFamily="34" charset="-122"/>
                 <a:cs typeface="Cambria" pitchFamily="34" charset="-120"/>
               </a:rPr>
-              <a:t>Coeficientes estimados: qué nos dice cada punto</a:t>
+              <a:t>Coeficientes</a:t>
+            </a:r>
+            <a:r>
+              <a:rPr lang="en-US" sz="3000" b="1" dirty="0">
+                <a:solidFill>
+                  <a:srgbClr val="2B2520"/>
+                </a:solidFill>
+                <a:latin typeface="Cambria" pitchFamily="34" charset="0"/>
+                <a:ea typeface="Cambria" pitchFamily="34" charset="-122"/>
+                <a:cs typeface="Cambria" pitchFamily="34" charset="-120"/>
+              </a:rPr>
+              <a:t> </a:t>
+            </a:r>
+            <a:r>
+              <a:rPr lang="en-US" sz="3000" b="1" dirty="0" err="1">
+                <a:solidFill>
+                  <a:srgbClr val="2B2520"/>
+                </a:solidFill>
+                <a:latin typeface="Cambria" pitchFamily="34" charset="0"/>
+                <a:ea typeface="Cambria" pitchFamily="34" charset="-122"/>
+                <a:cs typeface="Cambria" pitchFamily="34" charset="-120"/>
+              </a:rPr>
+              <a:t>estimados</a:t>
             </a:r>
             <a:endParaRPr lang="en-US" sz="3000" dirty="0"/>
           </a:p>
@@ -11326,7 +15022,29 @@
                 <a:ea typeface="Calibri" pitchFamily="34" charset="-122"/>
                 <a:cs typeface="Calibri" pitchFamily="34" charset="-120"/>
               </a:rPr>
-              <a:t>La barra muestra la incertidumbre</a:t>
+              <a:t>La barra muestra la </a:t>
+            </a:r>
+            <a:r>
+              <a:rPr lang="en-US" sz="1200" b="1" dirty="0" err="1">
+                <a:solidFill>
+                  <a:srgbClr val="8A6416"/>
+                </a:solidFill>
+                <a:latin typeface="Calibri" pitchFamily="34" charset="0"/>
+                <a:ea typeface="Calibri" pitchFamily="34" charset="-122"/>
+                <a:cs typeface="Calibri" pitchFamily="34" charset="-120"/>
+              </a:rPr>
+              <a:t>incertidumbre</a:t>
+            </a:r>
+            <a:r>
+              <a:rPr lang="en-US" sz="1200" b="1" dirty="0">
+                <a:solidFill>
+                  <a:srgbClr val="8A6416"/>
+                </a:solidFill>
+                <a:latin typeface="Calibri" pitchFamily="34" charset="0"/>
+                <a:ea typeface="Calibri" pitchFamily="34" charset="-122"/>
+                <a:cs typeface="Calibri" pitchFamily="34" charset="-120"/>
+              </a:rPr>
+              <a:t> (interval de confianza)</a:t>
             </a:r>
             <a:endParaRPr lang="en-US" sz="1200" dirty="0"/>
           </a:p>
@@ -11926,7 +15644,7 @@
         <p:spPr>
           <a:xfrm>
             <a:off x="7525512" y="5239512"/>
-            <a:ext cx="2770632" cy="219456"/>
+            <a:ext cx="3091688" cy="256032"/>
           </a:xfrm>
           <a:prstGeom prst="rect">
             <a:avLst/>
@@ -12064,7 +15782,7 @@
         </p:nvSpPr>
         <p:spPr>
           <a:xfrm>
-            <a:off x="7525512" y="5660136"/>
+            <a:off x="7507224" y="5669280"/>
             <a:ext cx="2770632" cy="219456"/>
           </a:xfrm>
           <a:prstGeom prst="rect">
@@ -18745,7 +22463,7 @@
                 <a:ea typeface="Calibri" pitchFamily="34" charset="-122"/>
                 <a:cs typeface="Calibri" pitchFamily="34" charset="-120"/>
               </a:rPr>
-              <a:t>Lectura correcta</a:t>
+              <a:t>Lectura</a:t>
             </a:r>
             <a:endParaRPr lang="en-US" sz="1200" dirty="0"/>
           </a:p>
@@ -32711,7 +36429,95 @@
                 <a:ea typeface="Calibri" pitchFamily="34" charset="-122"/>
                 <a:cs typeface="Calibri" pitchFamily="34" charset="-120"/>
               </a:rPr>
-              <a:t>Distribución, clima, eventos y efectos fijos de marca, región y subcanal: lo que se vendería sin publicidad.</a:t>
+              <a:t>Distribución, clima, eventos y efectos fijos de marca, de </a:t>
+            </a:r>
+            <a:r>
+              <a:rPr lang="en-US" sz="1050" dirty="0" err="1">
+                <a:solidFill>
+                  <a:srgbClr val="6E655B"/>
+                </a:solidFill>
+                <a:latin typeface="Calibri" pitchFamily="34" charset="0"/>
+                <a:ea typeface="Calibri" pitchFamily="34" charset="-122"/>
+                <a:cs typeface="Calibri" pitchFamily="34" charset="-120"/>
+              </a:rPr>
+              <a:t>región</a:t>
+            </a:r>
+            <a:r>
+              <a:rPr lang="en-US" sz="1050" dirty="0">
+                <a:solidFill>
+                  <a:srgbClr val="6E655B"/>
+                </a:solidFill>
+                <a:latin typeface="Calibri" pitchFamily="34" charset="0"/>
+                <a:ea typeface="Calibri" pitchFamily="34" charset="-122"/>
+                <a:cs typeface="Calibri" pitchFamily="34" charset="-120"/>
+              </a:rPr>
+              <a:t> y de </a:t>
+            </a:r>
+            <a:r>
+              <a:rPr lang="en-US" sz="1050" dirty="0" err="1">
+                <a:solidFill>
+                  <a:srgbClr val="6E655B"/>
+                </a:solidFill>
+                <a:latin typeface="Calibri" pitchFamily="34" charset="0"/>
+                <a:ea typeface="Calibri" pitchFamily="34" charset="-122"/>
+                <a:cs typeface="Calibri" pitchFamily="34" charset="-120"/>
+              </a:rPr>
+              <a:t>subcanal</a:t>
+            </a:r>
+            <a:r>
+              <a:rPr lang="en-US" sz="1050" dirty="0">
+                <a:solidFill>
+                  <a:srgbClr val="6E655B"/>
+                </a:solidFill>
+                <a:latin typeface="Calibri" pitchFamily="34" charset="0"/>
+                <a:ea typeface="Calibri" pitchFamily="34" charset="-122"/>
+                <a:cs typeface="Calibri" pitchFamily="34" charset="-120"/>
+              </a:rPr>
+              <a:t> </a:t>
+            </a:r>
+            <a:r>
+              <a:rPr lang="en-US" sz="1050" dirty="0" err="1">
+                <a:solidFill>
+                  <a:srgbClr val="6E655B"/>
+                </a:solidFill>
+                <a:latin typeface="Calibri" pitchFamily="34" charset="0"/>
+                <a:ea typeface="Calibri" pitchFamily="34" charset="-122"/>
+                <a:cs typeface="Calibri" pitchFamily="34" charset="-120"/>
+              </a:rPr>
+              <a:t>en</a:t>
+            </a:r>
+            <a:r>
+              <a:rPr lang="en-US" sz="1050" dirty="0">
+                <a:solidFill>
+                  <a:srgbClr val="6E655B"/>
+                </a:solidFill>
+                <a:latin typeface="Calibri" pitchFamily="34" charset="0"/>
+                <a:ea typeface="Calibri" pitchFamily="34" charset="-122"/>
+                <a:cs typeface="Calibri" pitchFamily="34" charset="-120"/>
+              </a:rPr>
+              <a:t> el </a:t>
+            </a:r>
+            <a:r>
+              <a:rPr lang="en-US" sz="1050" dirty="0" err="1">
+                <a:solidFill>
+                  <a:srgbClr val="6E655B"/>
+                </a:solidFill>
+                <a:latin typeface="Calibri" pitchFamily="34" charset="0"/>
+                <a:ea typeface="Calibri" pitchFamily="34" charset="-122"/>
+                <a:cs typeface="Calibri" pitchFamily="34" charset="-120"/>
+              </a:rPr>
+              <a:t>tiempo</a:t>
+            </a:r>
+            <a:r>
+              <a:rPr lang="en-US" sz="1050" dirty="0">
+                <a:solidFill>
+                  <a:srgbClr val="6E655B"/>
+                </a:solidFill>
+                <a:latin typeface="Calibri" pitchFamily="34" charset="0"/>
+                <a:ea typeface="Calibri" pitchFamily="34" charset="-122"/>
+                <a:cs typeface="Calibri" pitchFamily="34" charset="-120"/>
+              </a:rPr>
+              <a:t>: lo que se vendería sin publicidad.</a:t>
             </a:r>
             <a:endParaRPr lang="en-US" sz="1050" dirty="0"/>
           </a:p>
@@ -33017,7 +36823,7 @@
         <p:spPr>
           <a:xfrm>
             <a:off x="822960" y="5303520"/>
-            <a:ext cx="7863840" cy="822960"/>
+            <a:ext cx="8138160" cy="822960"/>
           </a:xfrm>
           <a:prstGeom prst="rect">
             <a:avLst/>
@@ -33041,20 +36847,8 @@
                 <a:ea typeface="Calibri" pitchFamily="34" charset="-122"/>
                 <a:cs typeface="Calibri" pitchFamily="34" charset="-120"/>
               </a:rPr>
-              <a:t>Notación.  </a:t>
-            </a:r>
-            <a:r>
-              <a:rPr lang="en-US" sz="1050" dirty="0">
-                <a:solidFill>
-                  <a:srgbClr val="FFFFFF"/>
-                </a:solidFill>
-                <a:latin typeface="Calibri" pitchFamily="34" charset="0"/>
-                <a:ea typeface="Calibri" pitchFamily="34" charset="-122"/>
-                <a:cs typeface="Calibri" pitchFamily="34" charset="-120"/>
-              </a:rPr>
-              <a:t>b marca, r región, s subcanal, t semana, j medio.  D distribución ponderada; C temperatura y precipitación; E eventos y feriados; M inversión en medios. Referencias: Marca C, Región A y Subcanal B.</a:t>
-            </a:r>
-            <a:endParaRPr lang="en-US" sz="1050" dirty="0"/>
+              <a:t>Notación. </a:t>
+            </a:r>
           </a:p>
           <a:p>
             <a:pPr marL="0" indent="0">
@@ -33063,13 +36857,167 @@
             <a:r>
               <a:rPr lang="en-US" sz="1050" dirty="0">
                 <a:solidFill>
+                  <a:srgbClr val="FFFFFF"/>
+                </a:solidFill>
+                <a:latin typeface="Calibri" pitchFamily="34" charset="0"/>
+                <a:ea typeface="Calibri" pitchFamily="34" charset="-122"/>
+                <a:cs typeface="Calibri" pitchFamily="34" charset="-120"/>
+              </a:rPr>
+              <a:t>b marca, r región, s subcanal, t semana, j medio.  </a:t>
+            </a:r>
+          </a:p>
+          <a:p>
+            <a:pPr marL="0" indent="0">
+              <a:buNone/>
+            </a:pPr>
+            <a:r>
+              <a:rPr lang="en-US" sz="1050" dirty="0">
+                <a:solidFill>
+                  <a:srgbClr val="FFFFFF"/>
+                </a:solidFill>
+                <a:latin typeface="Calibri" pitchFamily="34" charset="0"/>
+                <a:ea typeface="Calibri" pitchFamily="34" charset="-122"/>
+                <a:cs typeface="Calibri" pitchFamily="34" charset="-120"/>
+              </a:rPr>
+              <a:t>D distribución ponderada; C temperatura y precipitación; E eventos y feriados; M inversión en medios. Referencias: Marca C, Región A y Subcanal B.</a:t>
+            </a:r>
+            <a:endParaRPr lang="en-US" sz="1050" dirty="0"/>
+          </a:p>
+          <a:p>
+            <a:pPr marL="0" indent="0">
+              <a:buNone/>
+            </a:pPr>
+            <a:r>
+              <a:rPr lang="en-US" sz="1050" dirty="0" err="1">
+                <a:solidFill>
                   <a:srgbClr val="D9D0C2"/>
                 </a:solidFill>
                 <a:latin typeface="Calibri" pitchFamily="34" charset="0"/>
                 <a:ea typeface="Calibri" pitchFamily="34" charset="-122"/>
                 <a:cs typeface="Calibri" pitchFamily="34" charset="-120"/>
               </a:rPr>
-              <a:t>Estimación por mínimos cuadrados ordinarios; retransformación a hectolitros con smearing de Duan (factor 1,390).</a:t>
+              <a:t>Estimación</a:t>
+            </a:r>
+            <a:r>
+              <a:rPr lang="en-US" sz="1050" dirty="0">
+                <a:solidFill>
+                  <a:srgbClr val="D9D0C2"/>
+                </a:solidFill>
+                <a:latin typeface="Calibri" pitchFamily="34" charset="0"/>
+                <a:ea typeface="Calibri" pitchFamily="34" charset="-122"/>
+                <a:cs typeface="Calibri" pitchFamily="34" charset="-120"/>
+              </a:rPr>
+              <a:t> </a:t>
+            </a:r>
+            <a:r>
+              <a:rPr lang="en-US" sz="1050" dirty="0" err="1">
+                <a:solidFill>
+                  <a:srgbClr val="D9D0C2"/>
+                </a:solidFill>
+                <a:latin typeface="Calibri" pitchFamily="34" charset="0"/>
+                <a:ea typeface="Calibri" pitchFamily="34" charset="-122"/>
+                <a:cs typeface="Calibri" pitchFamily="34" charset="-120"/>
+              </a:rPr>
+              <a:t>por</a:t>
+            </a:r>
+            <a:r>
+              <a:rPr lang="en-US" sz="1050" dirty="0">
+                <a:solidFill>
+                  <a:srgbClr val="D9D0C2"/>
+                </a:solidFill>
+                <a:latin typeface="Calibri" pitchFamily="34" charset="0"/>
+                <a:ea typeface="Calibri" pitchFamily="34" charset="-122"/>
+                <a:cs typeface="Calibri" pitchFamily="34" charset="-120"/>
+              </a:rPr>
+              <a:t> </a:t>
+            </a:r>
+            <a:r>
+              <a:rPr lang="en-US" sz="1050" dirty="0" err="1">
+                <a:solidFill>
+                  <a:srgbClr val="D9D0C2"/>
+                </a:solidFill>
+                <a:latin typeface="Calibri" pitchFamily="34" charset="0"/>
+                <a:ea typeface="Calibri" pitchFamily="34" charset="-122"/>
+                <a:cs typeface="Calibri" pitchFamily="34" charset="-120"/>
+              </a:rPr>
+              <a:t>mínimos</a:t>
+            </a:r>
+            <a:r>
+              <a:rPr lang="en-US" sz="1050" dirty="0">
+                <a:solidFill>
+                  <a:srgbClr val="D9D0C2"/>
+                </a:solidFill>
+                <a:latin typeface="Calibri" pitchFamily="34" charset="0"/>
+                <a:ea typeface="Calibri" pitchFamily="34" charset="-122"/>
+                <a:cs typeface="Calibri" pitchFamily="34" charset="-120"/>
+              </a:rPr>
+              <a:t> </a:t>
+            </a:r>
+            <a:r>
+              <a:rPr lang="en-US" sz="1050" dirty="0" err="1">
+                <a:solidFill>
+                  <a:srgbClr val="D9D0C2"/>
+                </a:solidFill>
+                <a:latin typeface="Calibri" pitchFamily="34" charset="0"/>
+                <a:ea typeface="Calibri" pitchFamily="34" charset="-122"/>
+                <a:cs typeface="Calibri" pitchFamily="34" charset="-120"/>
+              </a:rPr>
+              <a:t>cuadrados</a:t>
+            </a:r>
+            <a:r>
+              <a:rPr lang="en-US" sz="1050" dirty="0">
+                <a:solidFill>
+                  <a:srgbClr val="D9D0C2"/>
+                </a:solidFill>
+                <a:latin typeface="Calibri" pitchFamily="34" charset="0"/>
+                <a:ea typeface="Calibri" pitchFamily="34" charset="-122"/>
+                <a:cs typeface="Calibri" pitchFamily="34" charset="-120"/>
+              </a:rPr>
+              <a:t> </a:t>
+            </a:r>
+            <a:r>
+              <a:rPr lang="en-US" sz="1050" dirty="0" err="1">
+                <a:solidFill>
+                  <a:srgbClr val="D9D0C2"/>
+                </a:solidFill>
+                <a:latin typeface="Calibri" pitchFamily="34" charset="0"/>
+                <a:ea typeface="Calibri" pitchFamily="34" charset="-122"/>
+                <a:cs typeface="Calibri" pitchFamily="34" charset="-120"/>
+              </a:rPr>
+              <a:t>ordinarios</a:t>
+            </a:r>
+            <a:r>
+              <a:rPr lang="en-US" sz="1050" dirty="0">
+                <a:solidFill>
+                  <a:srgbClr val="D9D0C2"/>
+                </a:solidFill>
+                <a:latin typeface="Calibri" pitchFamily="34" charset="0"/>
+                <a:ea typeface="Calibri" pitchFamily="34" charset="-122"/>
+                <a:cs typeface="Calibri" pitchFamily="34" charset="-120"/>
+              </a:rPr>
+              <a:t>; </a:t>
+            </a:r>
+            <a:r>
+              <a:rPr lang="en-US" sz="1050" dirty="0" err="1">
+                <a:solidFill>
+                  <a:srgbClr val="D9D0C2"/>
+                </a:solidFill>
+                <a:latin typeface="Calibri" pitchFamily="34" charset="0"/>
+                <a:ea typeface="Calibri" pitchFamily="34" charset="-122"/>
+                <a:cs typeface="Calibri" pitchFamily="34" charset="-120"/>
+              </a:rPr>
+              <a:t>retransformación</a:t>
+            </a:r>
+            <a:r>
+              <a:rPr lang="en-US" sz="1050" dirty="0">
+                <a:solidFill>
+                  <a:srgbClr val="D9D0C2"/>
+                </a:solidFill>
+                <a:latin typeface="Calibri" pitchFamily="34" charset="0"/>
+                <a:ea typeface="Calibri" pitchFamily="34" charset="-122"/>
+                <a:cs typeface="Calibri" pitchFamily="34" charset="-120"/>
+              </a:rPr>
+              <a:t> a hectolitros con smearing de Duan.</a:t>
             </a:r>
             <a:endParaRPr lang="en-US" sz="1050" dirty="0"/>
           </a:p>

</xml_diff>